<commit_message>
Lecture 14 demo: split into three stage scripts; remove offline mode
Rewrite the demo as three small scripts run in order, each adding exactly one idea
so they can be diffed side by side:
  stage1_chatbot.py - one LLM call per turn (no memory) -> forgets the run
  stage2_memory.py  - one running history (memory)      -> remembers, but invents
                       a QC number and passes a run that actually fails
  stage3_react.py   - the ReAct loop over tools         -> reads the file, flags
                       QC-04 OUT OF SPEC correctly

Remove the offline stand-in entirely: llm.py is now just claude(messages) calling
the Claude Messages API (raw HTTP), shared by all three; tools.py unchanged.
Delete the combined agent.py. README reworked around the three files + the diff;
deck instructor note and storyboard callout updated to stage1->stage2->stage3
(fallback is now a saved transcript, since there is no offline mode).
</commit_message>
<xml_diff>
--- a/slides/pptx/lecture14_agents.pptx
+++ b/slides/pptx/lecture14_agents.pptx
@@ -1654,7 +1654,7 @@
           <a:lstStyle/>
           <a:p>
             <a:r>
-              <a:t>The storyboard so the room knows what's coming and can map each step to the ReAct loop. Five beats: READ (open the CSV — an Action; the Thought before it: "I need the data first"), ANALYZE (run the limit checks and stats), PLOT (draw the spectra or QC trends), FLAG (mark the out-of-range run), and DRAFT (write a QC summary for a human to review). Narrate each as reason→act as the agent runs. Keep the room's hands in it: just before the FLAG beat, pause 30 seconds and have everyone PREDICT which run the agent will flag (they've already seen the QC-04 row on the follow-along handout), then run it and check the prediction — a quick hands-on beat inside the demo stretch. Emphasise two things the room should watch for: the agent shows its reasoning before each tool call (that's the ReAct transcript, live), and its final output is a DRAFT for review, never a released result — which sets up the guardrails stop. Restate the tooling plan: primary Claude Code, alternative Bedrock, fallback recording. Next slide, the flag→draft beat made concrete on the QC numbers. INSTRUCTOR NOTE — a ready-made, framework-free version of this demo lives in demos/lecture14_agent/. It builds the agent in THREE stages so the room sees why each piece matters: `python3 agent.py 1` (chatbot — can't see the data), `2` (adds memory — fluent but INVENTS QC numbers, a live hallucination), `3` (adds tools/ReAct — reads the file and answers with the real QC-04 numbers, hallucination gone). One small loop with two switches (memory, tools); tools and the LLM backend are in separate files. Runs OFFLINE with no API key as the guaranteed fallback, or against the real Claude API with `--claude`. Open agent.py on screen: an agent is just LLM + tools + a loop, no magic.</a:t>
+              <a:t>The storyboard so the room knows what's coming and can map each step to the ReAct loop. Five beats: READ (open the CSV — an Action; the Thought before it: "I need the data first"), ANALYZE (run the limit checks and stats), PLOT (draw the spectra or QC trends), FLAG (mark the out-of-range run), and DRAFT (write a QC summary for a human to review). Narrate each as reason→act as the agent runs. Keep the room's hands in it: just before the FLAG beat, pause 30 seconds and have everyone PREDICT which run the agent will flag (they've already seen the QC-04 row on the follow-along handout), then run it and check the prediction — a quick hands-on beat inside the demo stretch. Emphasise two things the room should watch for: the agent shows its reasoning before each tool call (that's the ReAct transcript, live), and its final output is a DRAFT for review, never a released result — which sets up the guardrails stop. Restate the tooling plan: primary Claude Code, alternative Bedrock, fallback recording. Next slide, the flag→draft beat made concrete on the QC numbers. INSTRUCTOR NOTE — a ready-made, framework-free version of this demo lives in demos/lecture14_agent/, built as THREE small scripts run in order so the room sees why each piece matters: `python3 stage1_chatbot.py` (bare LLM — forgets the run we just named), `stage2_memory.py` (adds a running history — now it remembers, but INVENTS a QC number and passes a run that actually fails), and `stage3_react.py` (adds tools/ReAct — reads the file and correctly flags QC-04 OUT OF SPEC). Each file adds exactly one idea; open them side by side and diff. Uses the real Claude API (ANTHROPIC_API_KEY); the shared call is in llm.py and the tools in tools.py. An agent is just LLM + memory + tools + a loop, no magic.</a:t>
             </a:r>
           </a:p>
           <a:p/>
@@ -8555,8 +8555,8 @@
         </p:blipFill>
         <p:spPr>
           <a:xfrm>
-            <a:off x="1706020" y="1828800"/>
-            <a:ext cx="8749480" cy="3099816"/>
+            <a:off x="1340381" y="1828800"/>
+            <a:ext cx="9480757" cy="3358897"/>
           </a:xfrm>
           <a:prstGeom prst="rect">
             <a:avLst/>
@@ -8571,8 +8571,8 @@
         </p:nvSpPr>
         <p:spPr>
           <a:xfrm>
-            <a:off x="548640" y="5020056"/>
-            <a:ext cx="10515600" cy="1700784"/>
+            <a:off x="548640" y="5279137"/>
+            <a:ext cx="10515600" cy="1441703"/>
           </a:xfrm>
           <a:prstGeom prst="rect">
             <a:avLst/>
@@ -8622,7 +8622,7 @@
                 </a:solidFill>
                 <a:latin typeface="Avenir Next"/>
               </a:rPr>
-              <a:t>The demo as five beats, each one reason→act: READ the QC/spectra CSV → ANALYZE (limits, stats) → PLOT the spectra/trends → FLAG the out-of-range run → DRAFT the QC summary for review. 💬 Before the FLAG beat, take 30 s: predict which run the agent will flag. Primary: instructor's Claude Code (or demos/lecture14_agent/agent.py, staged 1→2→3) · fallback: offline run — the demo never fails live.</a:t>
+              <a:t>The demo as five beats, each one reason→act: READ the QC/spectra CSV → ANALYZE (limits, stats) → PLOT the spectra/trends → FLAG the out-of-range run → DRAFT the QC summary for review. 💬 Before the FLAG beat, take 30 s: predict which run the agent will flag. Primary: instructor's Claude Code (or demos/lecture14_agent/, run stage1→stage2→stage3) · fallback: a saved transcript — the demo never fails live.</a:t>
             </a:r>
           </a:p>
         </p:txBody>

</xml_diff>

<commit_message>
slides: adopt the course template in lecture 14
Co-Authored-By: Claude Opus 5 <noreply@anthropic.com>
</commit_message>
<xml_diff>
--- a/slides/pptx/lecture14_agents.pptx
+++ b/slides/pptx/lecture14_agents.pptx
@@ -2,7 +2,7 @@
 <file path=ppt/presentation.xml><?xml version="1.0" encoding="utf-8"?>
 <p:presentation xmlns:a="http://schemas.openxmlformats.org/drawingml/2006/main" xmlns:r="http://schemas.openxmlformats.org/officeDocument/2006/relationships" xmlns:p="http://schemas.openxmlformats.org/presentationml/2006/main" saveSubsetFonts="1" autoCompressPictures="0">
   <p:sldMasterIdLst>
-    <p:sldMasterId id="2147483648" r:id="rId1"/>
+    <p:sldMasterId id="2147483658" r:id="rId1"/>
   </p:sldMasterIdLst>
   <p:sldIdLst>
     <p:sldId id="256" r:id="rId7"/>
@@ -1680,7 +1680,7 @@
 </p:notes>
 </file>
 
-<file path=ppt/slideLayouts/slideLayout1.xml><?xml version="1.0" encoding="utf-8"?>
+<file path=ppt/slideLayouts/slideLayout18.xml><?xml version="1.0" encoding="utf-8"?>
 <p:sldLayout xmlns:a="http://schemas.openxmlformats.org/drawingml/2006/main" xmlns:r="http://schemas.openxmlformats.org/officeDocument/2006/relationships" xmlns:p="http://schemas.openxmlformats.org/presentationml/2006/main" type="title" preserve="1">
   <p:cSld name="Title Slide">
     <p:spTree>
@@ -1709,13 +1709,23 @@
         </p:nvSpPr>
         <p:spPr>
           <a:xfrm>
-            <a:off x="685800" y="2130425"/>
-            <a:ext cx="7772400" cy="1470025"/>
-          </a:xfrm>
-        </p:spPr>
-        <p:txBody>
-          <a:bodyPr/>
-          <a:lstStyle/>
+            <a:off x="548640" y="2286000"/>
+            <a:ext cx="11091672" cy="1371600"/>
+          </a:xfrm>
+        </p:spPr>
+        <p:txBody>
+          <a:bodyPr wrap="square" anchor="t"/>
+          <a:lstStyle>
+            <a:lvl1pPr marL="0" indent="0" algn="l">
+              <a:buNone/>
+              <a:defRPr sz="4400" b="1">
+                <a:solidFill>
+                  <a:schemeClr val="tx1"/>
+                </a:solidFill>
+                <a:latin typeface="+mn-lt"/>
+              </a:defRPr>
+            </a:lvl1pPr>
+          </a:lstStyle>
           <a:p>
             <a:r>
               <a:rPr lang="en-US" smtClean="0"/>
@@ -1737,176 +1747,96 @@
         </p:nvSpPr>
         <p:spPr>
           <a:xfrm>
-            <a:off x="1371600" y="3886200"/>
-            <a:ext cx="6400800" cy="1752600"/>
-          </a:xfrm>
-        </p:spPr>
-        <p:txBody>
-          <a:bodyPr/>
+            <a:off x="548640" y="3840480"/>
+            <a:ext cx="11091672" cy="914400"/>
+          </a:xfrm>
+        </p:spPr>
+        <p:txBody>
+          <a:bodyPr wrap="square" anchor="t"/>
           <a:lstStyle>
-            <a:lvl1pPr marL="0" indent="0" algn="ctr">
+            <a:lvl1pPr marL="0" indent="0" algn="l">
               <a:buNone/>
-              <a:defRPr>
-                <a:solidFill>
-                  <a:schemeClr val="tx1">
-                    <a:tint val="75000"/>
-                  </a:schemeClr>
-                </a:solidFill>
+              <a:defRPr sz="2200">
+                <a:solidFill>
+                  <a:schemeClr val="accent1"/>
+                </a:solidFill>
+                <a:latin typeface="+mn-lt"/>
               </a:defRPr>
             </a:lvl1pPr>
-            <a:lvl2pPr marL="457200" indent="0" algn="ctr">
-              <a:buNone/>
-              <a:defRPr>
-                <a:solidFill>
-                  <a:schemeClr val="tx1">
-                    <a:tint val="75000"/>
-                  </a:schemeClr>
-                </a:solidFill>
-              </a:defRPr>
-            </a:lvl2pPr>
-            <a:lvl3pPr marL="914400" indent="0" algn="ctr">
-              <a:buNone/>
-              <a:defRPr>
-                <a:solidFill>
-                  <a:schemeClr val="tx1">
-                    <a:tint val="75000"/>
-                  </a:schemeClr>
-                </a:solidFill>
-              </a:defRPr>
-            </a:lvl3pPr>
-            <a:lvl4pPr marL="1371600" indent="0" algn="ctr">
-              <a:buNone/>
-              <a:defRPr>
-                <a:solidFill>
-                  <a:schemeClr val="tx1">
-                    <a:tint val="75000"/>
-                  </a:schemeClr>
-                </a:solidFill>
-              </a:defRPr>
-            </a:lvl4pPr>
-            <a:lvl5pPr marL="1828800" indent="0" algn="ctr">
-              <a:buNone/>
-              <a:defRPr>
-                <a:solidFill>
-                  <a:schemeClr val="tx1">
-                    <a:tint val="75000"/>
-                  </a:schemeClr>
-                </a:solidFill>
-              </a:defRPr>
-            </a:lvl5pPr>
-            <a:lvl6pPr marL="2286000" indent="0" algn="ctr">
-              <a:buNone/>
-              <a:defRPr>
-                <a:solidFill>
-                  <a:schemeClr val="tx1">
-                    <a:tint val="75000"/>
-                  </a:schemeClr>
-                </a:solidFill>
-              </a:defRPr>
-            </a:lvl6pPr>
-            <a:lvl7pPr marL="2743200" indent="0" algn="ctr">
-              <a:buNone/>
-              <a:defRPr>
-                <a:solidFill>
-                  <a:schemeClr val="tx1">
-                    <a:tint val="75000"/>
-                  </a:schemeClr>
-                </a:solidFill>
-              </a:defRPr>
-            </a:lvl7pPr>
-            <a:lvl8pPr marL="3200400" indent="0" algn="ctr">
-              <a:buNone/>
-              <a:defRPr>
-                <a:solidFill>
-                  <a:schemeClr val="tx1">
-                    <a:tint val="75000"/>
-                  </a:schemeClr>
-                </a:solidFill>
-              </a:defRPr>
-            </a:lvl8pPr>
-            <a:lvl9pPr marL="3657600" indent="0" algn="ctr">
-              <a:buNone/>
-              <a:defRPr>
-                <a:solidFill>
-                  <a:schemeClr val="tx1">
-                    <a:tint val="75000"/>
-                  </a:schemeClr>
-                </a:solidFill>
-              </a:defRPr>
-            </a:lvl9pPr>
           </a:lstStyle>
           <a:p>
             <a:r>
-              <a:rPr lang="en-US" smtClean="0"/>
-              <a:t>Click to edit Master subtitle style</a:t>
-            </a:r>
-            <a:endParaRPr lang="en-US"/>
-          </a:p>
-        </p:txBody>
-      </p:sp>
-      <p:sp>
-        <p:nvSpPr>
-          <p:cNvPr id="4" name="Date Placeholder 3"/>
+              <a:rPr lang="en-US"/>
+              <a:t>Click to add a one-line subtitle</a:t>
+            </a:r>
+          </a:p>
+        </p:txBody>
+      </p:sp>
+      <p:sp>
+        <p:nvSpPr>
+          <p:cNvPr id="4" name="Eyebrow Placeholder"/>
           <p:cNvSpPr>
             <a:spLocks noGrp="1"/>
           </p:cNvSpPr>
           <p:nvPr>
-            <p:ph type="dt" sz="half" idx="10"/>
+            <p:ph type="body" sz="quarter" idx="13"/>
           </p:nvPr>
         </p:nvSpPr>
-        <p:spPr/>
+        <p:spPr>
+          <a:xfrm>
+            <a:off x="548640" y="320040"/>
+            <a:ext cx="11091672" cy="365760"/>
+          </a:xfrm>
+          <a:prstGeom prst="rect">
+            <a:avLst/>
+          </a:prstGeom>
+        </p:spPr>
+        <p:txBody>
+          <a:bodyPr wrap="square" anchor="t"/>
+          <a:lstStyle>
+            <a:lvl1pPr marL="0" indent="0">
+              <a:buNone/>
+              <a:defRPr sz="1300" b="1" cap="all">
+                <a:solidFill>
+                  <a:schemeClr val="accent4"/>
+                </a:solidFill>
+                <a:latin typeface="Menlo"/>
+              </a:defRPr>
+            </a:lvl1pPr>
+          </a:lstStyle>
+          <a:p>
+            <a:r>
+              <a:rPr lang="en-US"/>
+              <a:t>MSACL · DS301 Deep Learning · Segment n · Lecture n</a:t>
+            </a:r>
+          </a:p>
+        </p:txBody>
+      </p:sp>
+      <p:sp>
+        <p:nvSpPr>
+          <p:cNvPr id="5" name="Amber bar"/>
+          <p:cNvSpPr/>
+          <p:nvPr/>
+        </p:nvSpPr>
+        <p:spPr>
+          <a:xfrm>
+            <a:off x="548640" y="2057400"/>
+            <a:ext cx="1280160" cy="54864"/>
+          </a:xfrm>
+          <a:prstGeom prst="rect">
+            <a:avLst/>
+          </a:prstGeom>
+          <a:solidFill>
+            <a:schemeClr val="accent2"/>
+          </a:solidFill>
+          <a:ln>
+            <a:noFill/>
+          </a:ln>
+        </p:spPr>
         <p:txBody>
           <a:bodyPr/>
           <a:lstStyle/>
-          <a:p>
-            <a:fld id="{5BCAD085-E8A6-8845-BD4E-CB4CCA059FC4}" type="datetimeFigureOut">
-              <a:rPr lang="en-US" smtClean="0"/>
-              <a:t>1/27/13</a:t>
-            </a:fld>
-            <a:endParaRPr lang="en-US"/>
-          </a:p>
-        </p:txBody>
-      </p:sp>
-      <p:sp>
-        <p:nvSpPr>
-          <p:cNvPr id="5" name="Footer Placeholder 4"/>
-          <p:cNvSpPr>
-            <a:spLocks noGrp="1"/>
-          </p:cNvSpPr>
-          <p:nvPr>
-            <p:ph type="ftr" sz="quarter" idx="11"/>
-          </p:nvPr>
-        </p:nvSpPr>
-        <p:spPr/>
-        <p:txBody>
-          <a:bodyPr/>
-          <a:lstStyle/>
-          <a:p>
-            <a:endParaRPr lang="en-US"/>
-          </a:p>
-        </p:txBody>
-      </p:sp>
-      <p:sp>
-        <p:nvSpPr>
-          <p:cNvPr id="6" name="Slide Number Placeholder 5"/>
-          <p:cNvSpPr>
-            <a:spLocks noGrp="1"/>
-          </p:cNvSpPr>
-          <p:nvPr>
-            <p:ph type="sldNum" sz="quarter" idx="12"/>
-          </p:nvPr>
-        </p:nvSpPr>
-        <p:spPr/>
-        <p:txBody>
-          <a:bodyPr/>
-          <a:lstStyle/>
-          <a:p>
-            <a:fld id="{C1FF6DA9-008F-8B48-92A6-B652298478BF}" type="slidenum">
-              <a:rPr lang="en-US" smtClean="0"/>
-              <a:t>‹#›</a:t>
-            </a:fld>
-            <a:endParaRPr lang="en-US"/>
-          </a:p>
+          <a:p/>
         </p:txBody>
       </p:sp>
     </p:spTree>
@@ -1922,9 +1852,9 @@
 </p:sldLayout>
 </file>
 
-<file path=ppt/slideLayouts/slideLayout10.xml><?xml version="1.0" encoding="utf-8"?>
-<p:sldLayout xmlns:a="http://schemas.openxmlformats.org/drawingml/2006/main" xmlns:r="http://schemas.openxmlformats.org/officeDocument/2006/relationships" xmlns:p="http://schemas.openxmlformats.org/presentationml/2006/main" type="vertTx" preserve="1">
-  <p:cSld name="Title and Vertical Text">
+<file path=ppt/slideLayouts/slideLayout19.xml><?xml version="1.0" encoding="utf-8"?>
+<p:sldLayout xmlns:a="http://schemas.openxmlformats.org/drawingml/2006/main" xmlns:r="http://schemas.openxmlformats.org/officeDocument/2006/relationships" xmlns:p="http://schemas.openxmlformats.org/presentationml/2006/main" type="obj" preserve="1">
+  <p:cSld name="Title and Body">
     <p:spTree>
       <p:nvGrpSpPr>
         <p:cNvPr id="1" name=""/>
@@ -1949,9 +1879,14 @@
             <p:ph type="title"/>
           </p:nvPr>
         </p:nvSpPr>
-        <p:spPr/>
-        <p:txBody>
-          <a:bodyPr/>
+        <p:spPr>
+          <a:xfrm>
+            <a:off x="548640" y="731520"/>
+            <a:ext cx="11091672" cy="1005840"/>
+          </a:xfrm>
+        </p:spPr>
+        <p:txBody>
+          <a:bodyPr wrap="square" anchor="t"/>
           <a:lstStyle/>
           <a:p>
             <a:r>
@@ -1964,17 +1899,22 @@
       </p:sp>
       <p:sp>
         <p:nvSpPr>
-          <p:cNvPr id="3" name="Vertical Text Placeholder 2"/>
+          <p:cNvPr id="3" name="Content Placeholder 2"/>
           <p:cNvSpPr>
             <a:spLocks noGrp="1"/>
           </p:cNvSpPr>
           <p:nvPr>
-            <p:ph type="body" orient="vert" idx="1"/>
+            <p:ph idx="1"/>
           </p:nvPr>
         </p:nvSpPr>
-        <p:spPr/>
-        <p:txBody>
-          <a:bodyPr vert="eaVert"/>
+        <p:spPr>
+          <a:xfrm>
+            <a:off x="548640" y="1920240"/>
+            <a:ext cx="11091672" cy="4434840"/>
+          </a:xfrm>
+        </p:spPr>
+        <p:txBody>
+          <a:bodyPr wrap="square" anchor="t"/>
           <a:lstStyle/>
           <a:p>
             <a:pPr lvl="0"/>
@@ -2016,73 +1956,48 @@
       </p:sp>
       <p:sp>
         <p:nvSpPr>
-          <p:cNvPr id="4" name="Date Placeholder 3"/>
+          <p:cNvPr id="4" name="Eyebrow Placeholder"/>
           <p:cNvSpPr>
             <a:spLocks noGrp="1"/>
           </p:cNvSpPr>
           <p:nvPr>
-            <p:ph type="dt" sz="half" idx="10"/>
+            <p:ph type="body" sz="quarter" idx="13"/>
           </p:nvPr>
         </p:nvSpPr>
-        <p:spPr/>
-        <p:txBody>
-          <a:bodyPr/>
-          <a:lstStyle/>
-          <a:p>
-            <a:fld id="{5BCAD085-E8A6-8845-BD4E-CB4CCA059FC4}" type="datetimeFigureOut">
-              <a:rPr lang="en-US" smtClean="0"/>
-              <a:t>1/27/13</a:t>
-            </a:fld>
-            <a:endParaRPr lang="en-US"/>
-          </a:p>
-        </p:txBody>
-      </p:sp>
-      <p:sp>
-        <p:nvSpPr>
-          <p:cNvPr id="5" name="Footer Placeholder 4"/>
-          <p:cNvSpPr>
-            <a:spLocks noGrp="1"/>
-          </p:cNvSpPr>
-          <p:nvPr>
-            <p:ph type="ftr" sz="quarter" idx="11"/>
-          </p:nvPr>
-        </p:nvSpPr>
-        <p:spPr/>
-        <p:txBody>
-          <a:bodyPr/>
-          <a:lstStyle/>
-          <a:p>
-            <a:endParaRPr lang="en-US"/>
-          </a:p>
-        </p:txBody>
-      </p:sp>
-      <p:sp>
-        <p:nvSpPr>
-          <p:cNvPr id="6" name="Slide Number Placeholder 5"/>
-          <p:cNvSpPr>
-            <a:spLocks noGrp="1"/>
-          </p:cNvSpPr>
-          <p:nvPr>
-            <p:ph type="sldNum" sz="quarter" idx="12"/>
-          </p:nvPr>
-        </p:nvSpPr>
-        <p:spPr/>
-        <p:txBody>
-          <a:bodyPr/>
-          <a:lstStyle/>
-          <a:p>
-            <a:fld id="{C1FF6DA9-008F-8B48-92A6-B652298478BF}" type="slidenum">
-              <a:rPr lang="en-US" smtClean="0"/>
-              <a:t>‹#›</a:t>
-            </a:fld>
-            <a:endParaRPr lang="en-US"/>
+        <p:spPr>
+          <a:xfrm>
+            <a:off x="548640" y="320040"/>
+            <a:ext cx="11091672" cy="365760"/>
+          </a:xfrm>
+          <a:prstGeom prst="rect">
+            <a:avLst/>
+          </a:prstGeom>
+        </p:spPr>
+        <p:txBody>
+          <a:bodyPr wrap="square" anchor="t"/>
+          <a:lstStyle>
+            <a:lvl1pPr marL="0" indent="0">
+              <a:buNone/>
+              <a:defRPr sz="1300" b="1" cap="all">
+                <a:solidFill>
+                  <a:schemeClr val="accent4"/>
+                </a:solidFill>
+                <a:latin typeface="Menlo"/>
+              </a:defRPr>
+            </a:lvl1pPr>
+          </a:lstStyle>
+          <a:p>
+            <a:r>
+              <a:rPr lang="en-US"/>
+              <a:t>MSACL · DS301 Deep Learning · Segment n · Lecture n</a:t>
+            </a:r>
           </a:p>
         </p:txBody>
       </p:sp>
     </p:spTree>
     <p:extLst>
       <p:ext uri="{BB962C8B-B14F-4D97-AF65-F5344CB8AC3E}">
-        <p14:creationId xmlns:p14="http://schemas.microsoft.com/office/powerpoint/2010/main" val="2910927964"/>
+        <p14:creationId xmlns:p14="http://schemas.microsoft.com/office/powerpoint/2010/main" val="2614314258"/>
       </p:ext>
     </p:extLst>
   </p:cSld>
@@ -2092,9 +2007,9 @@
 </p:sldLayout>
 </file>
 
-<file path=ppt/slideLayouts/slideLayout11.xml><?xml version="1.0" encoding="utf-8"?>
-<p:sldLayout xmlns:a="http://schemas.openxmlformats.org/drawingml/2006/main" xmlns:r="http://schemas.openxmlformats.org/officeDocument/2006/relationships" xmlns:p="http://schemas.openxmlformats.org/presentationml/2006/main" type="vertTitleAndTx" preserve="1">
-  <p:cSld name="Vertical Title and Text">
+<file path=ppt/slideLayouts/slideLayout20.xml><?xml version="1.0" encoding="utf-8"?>
+<p:sldLayout xmlns:a="http://schemas.openxmlformats.org/drawingml/2006/main" xmlns:r="http://schemas.openxmlformats.org/officeDocument/2006/relationships" xmlns:p="http://schemas.openxmlformats.org/presentationml/2006/main" type="twoObj" preserve="1">
+  <p:cSld name="Two Column">
     <p:spTree>
       <p:nvGrpSpPr>
         <p:cNvPr id="1" name=""/>
@@ -2111,22 +2026,22 @@
       </p:grpSpPr>
       <p:sp>
         <p:nvSpPr>
-          <p:cNvPr id="2" name="Vertical Title 1"/>
+          <p:cNvPr id="2" name="Title 1"/>
           <p:cNvSpPr>
             <a:spLocks noGrp="1"/>
           </p:cNvSpPr>
           <p:nvPr>
-            <p:ph type="title" orient="vert"/>
+            <p:ph type="title"/>
           </p:nvPr>
         </p:nvSpPr>
         <p:spPr>
           <a:xfrm>
-            <a:off x="6629400" y="274638"/>
-            <a:ext cx="2057400" cy="5851525"/>
-          </a:xfrm>
-        </p:spPr>
-        <p:txBody>
-          <a:bodyPr vert="eaVert"/>
+            <a:off x="548640" y="731520"/>
+            <a:ext cx="11091672" cy="1005840"/>
+          </a:xfrm>
+        </p:spPr>
+        <p:txBody>
+          <a:bodyPr wrap="square" anchor="t"/>
           <a:lstStyle/>
           <a:p>
             <a:r>
@@ -2139,23 +2054,40 @@
       </p:sp>
       <p:sp>
         <p:nvSpPr>
-          <p:cNvPr id="3" name="Vertical Text Placeholder 2"/>
+          <p:cNvPr id="3" name="Content Placeholder 2"/>
           <p:cNvSpPr>
             <a:spLocks noGrp="1"/>
           </p:cNvSpPr>
           <p:nvPr>
-            <p:ph type="body" orient="vert" idx="1"/>
+            <p:ph sz="half" idx="1"/>
           </p:nvPr>
         </p:nvSpPr>
         <p:spPr>
           <a:xfrm>
-            <a:off x="457200" y="274638"/>
-            <a:ext cx="6019800" cy="5851525"/>
-          </a:xfrm>
-        </p:spPr>
-        <p:txBody>
-          <a:bodyPr vert="eaVert"/>
-          <a:lstStyle/>
+            <a:off x="548640" y="1920240"/>
+            <a:ext cx="5367528" cy="4434840"/>
+          </a:xfrm>
+        </p:spPr>
+        <p:txBody>
+          <a:bodyPr wrap="square" anchor="t"/>
+          <a:lstStyle>
+            <a:lvl1pPr marL="274638" indent="-274638">
+              <a:spcAft>
+                <a:spcPts val="1400"/>
+              </a:spcAft>
+              <a:buClr>
+                <a:schemeClr val="accent1"/>
+              </a:buClr>
+              <a:buFont typeface="Arial"/>
+              <a:buChar char="•"/>
+              <a:defRPr sz="2200">
+                <a:solidFill>
+                  <a:schemeClr val="tx1"/>
+                </a:solidFill>
+                <a:latin typeface="+mn-lt"/>
+              </a:defRPr>
+            </a:lvl1pPr>
+          </a:lstStyle>
           <a:p>
             <a:pPr lvl="0"/>
             <a:r>
@@ -2196,73 +2128,122 @@
       </p:sp>
       <p:sp>
         <p:nvSpPr>
-          <p:cNvPr id="4" name="Date Placeholder 3"/>
+          <p:cNvPr id="4" name="Content Placeholder 3"/>
           <p:cNvSpPr>
             <a:spLocks noGrp="1"/>
           </p:cNvSpPr>
           <p:nvPr>
-            <p:ph type="dt" sz="half" idx="10"/>
+            <p:ph sz="half" idx="2"/>
           </p:nvPr>
         </p:nvSpPr>
-        <p:spPr/>
-        <p:txBody>
-          <a:bodyPr/>
-          <a:lstStyle/>
-          <a:p>
-            <a:fld id="{5BCAD085-E8A6-8845-BD4E-CB4CCA059FC4}" type="datetimeFigureOut">
+        <p:spPr>
+          <a:xfrm>
+            <a:off x="6281928" y="1920240"/>
+            <a:ext cx="5367528" cy="4434840"/>
+          </a:xfrm>
+        </p:spPr>
+        <p:txBody>
+          <a:bodyPr wrap="square" anchor="t"/>
+          <a:lstStyle>
+            <a:lvl1pPr marL="274638" indent="-274638">
+              <a:spcAft>
+                <a:spcPts val="1400"/>
+              </a:spcAft>
+              <a:buClr>
+                <a:schemeClr val="accent1"/>
+              </a:buClr>
+              <a:buFont typeface="Arial"/>
+              <a:buChar char="•"/>
+              <a:defRPr sz="2200">
+                <a:solidFill>
+                  <a:schemeClr val="tx1"/>
+                </a:solidFill>
+                <a:latin typeface="+mn-lt"/>
+              </a:defRPr>
+            </a:lvl1pPr>
+          </a:lstStyle>
+          <a:p>
+            <a:pPr lvl="0"/>
+            <a:r>
               <a:rPr lang="en-US" smtClean="0"/>
-              <a:t>1/27/13</a:t>
-            </a:fld>
+              <a:t>Click to edit Master text styles</a:t>
+            </a:r>
+          </a:p>
+          <a:p>
+            <a:pPr lvl="1"/>
+            <a:r>
+              <a:rPr lang="en-US" smtClean="0"/>
+              <a:t>Second level</a:t>
+            </a:r>
+          </a:p>
+          <a:p>
+            <a:pPr lvl="2"/>
+            <a:r>
+              <a:rPr lang="en-US" smtClean="0"/>
+              <a:t>Third level</a:t>
+            </a:r>
+          </a:p>
+          <a:p>
+            <a:pPr lvl="3"/>
+            <a:r>
+              <a:rPr lang="en-US" smtClean="0"/>
+              <a:t>Fourth level</a:t>
+            </a:r>
+          </a:p>
+          <a:p>
+            <a:pPr lvl="4"/>
+            <a:r>
+              <a:rPr lang="en-US" smtClean="0"/>
+              <a:t>Fifth level</a:t>
+            </a:r>
             <a:endParaRPr lang="en-US"/>
           </a:p>
         </p:txBody>
       </p:sp>
       <p:sp>
         <p:nvSpPr>
-          <p:cNvPr id="5" name="Footer Placeholder 4"/>
+          <p:cNvPr id="5" name="Eyebrow Placeholder"/>
           <p:cNvSpPr>
             <a:spLocks noGrp="1"/>
           </p:cNvSpPr>
           <p:nvPr>
-            <p:ph type="ftr" sz="quarter" idx="11"/>
+            <p:ph type="body" sz="quarter" idx="13"/>
           </p:nvPr>
         </p:nvSpPr>
-        <p:spPr/>
-        <p:txBody>
-          <a:bodyPr/>
-          <a:lstStyle/>
-          <a:p>
-            <a:endParaRPr lang="en-US"/>
-          </a:p>
-        </p:txBody>
-      </p:sp>
-      <p:sp>
-        <p:nvSpPr>
-          <p:cNvPr id="6" name="Slide Number Placeholder 5"/>
-          <p:cNvSpPr>
-            <a:spLocks noGrp="1"/>
-          </p:cNvSpPr>
-          <p:nvPr>
-            <p:ph type="sldNum" sz="quarter" idx="12"/>
-          </p:nvPr>
-        </p:nvSpPr>
-        <p:spPr/>
-        <p:txBody>
-          <a:bodyPr/>
-          <a:lstStyle/>
-          <a:p>
-            <a:fld id="{C1FF6DA9-008F-8B48-92A6-B652298478BF}" type="slidenum">
-              <a:rPr lang="en-US" smtClean="0"/>
-              <a:t>‹#›</a:t>
-            </a:fld>
-            <a:endParaRPr lang="en-US"/>
+        <p:spPr>
+          <a:xfrm>
+            <a:off x="548640" y="320040"/>
+            <a:ext cx="11091672" cy="365760"/>
+          </a:xfrm>
+          <a:prstGeom prst="rect">
+            <a:avLst/>
+          </a:prstGeom>
+        </p:spPr>
+        <p:txBody>
+          <a:bodyPr wrap="square" anchor="t"/>
+          <a:lstStyle>
+            <a:lvl1pPr marL="0" indent="0">
+              <a:buNone/>
+              <a:defRPr sz="1300" b="1" cap="all">
+                <a:solidFill>
+                  <a:schemeClr val="accent4"/>
+                </a:solidFill>
+                <a:latin typeface="Menlo"/>
+              </a:defRPr>
+            </a:lvl1pPr>
+          </a:lstStyle>
+          <a:p>
+            <a:r>
+              <a:rPr lang="en-US"/>
+              <a:t>MSACL · DS301 Deep Learning · Segment n · Lecture n</a:t>
+            </a:r>
           </a:p>
         </p:txBody>
       </p:sp>
     </p:spTree>
     <p:extLst>
       <p:ext uri="{BB962C8B-B14F-4D97-AF65-F5344CB8AC3E}">
-        <p14:creationId xmlns:p14="http://schemas.microsoft.com/office/powerpoint/2010/main" val="3612223792"/>
+        <p14:creationId xmlns:p14="http://schemas.microsoft.com/office/powerpoint/2010/main" val="2782244947"/>
       </p:ext>
     </p:extLst>
   </p:cSld>
@@ -2272,9 +2253,9 @@
 </p:sldLayout>
 </file>
 
-<file path=ppt/slideLayouts/slideLayout2.xml><?xml version="1.0" encoding="utf-8"?>
-<p:sldLayout xmlns:a="http://schemas.openxmlformats.org/drawingml/2006/main" xmlns:r="http://schemas.openxmlformats.org/officeDocument/2006/relationships" xmlns:p="http://schemas.openxmlformats.org/presentationml/2006/main" type="obj" preserve="1">
-  <p:cSld name="Title and Content">
+<file path=ppt/slideLayouts/slideLayout21.xml><?xml version="1.0" encoding="utf-8"?>
+<p:sldLayout xmlns:a="http://schemas.openxmlformats.org/drawingml/2006/main" xmlns:r="http://schemas.openxmlformats.org/officeDocument/2006/relationships" xmlns:p="http://schemas.openxmlformats.org/presentationml/2006/main" type="picTx" preserve="1">
+  <p:cSld name="Screenshot + Caption">
     <p:spTree>
       <p:nvGrpSpPr>
         <p:cNvPr id="1" name=""/>
@@ -2299,1630 +2280,14 @@
             <p:ph type="title"/>
           </p:nvPr>
         </p:nvSpPr>
-        <p:spPr/>
-        <p:txBody>
-          <a:bodyPr/>
-          <a:lstStyle/>
-          <a:p>
-            <a:r>
-              <a:rPr lang="en-US" smtClean="0"/>
-              <a:t>Click to edit Master title style</a:t>
-            </a:r>
-            <a:endParaRPr lang="en-US"/>
-          </a:p>
-        </p:txBody>
-      </p:sp>
-      <p:sp>
-        <p:nvSpPr>
-          <p:cNvPr id="3" name="Content Placeholder 2"/>
-          <p:cNvSpPr>
-            <a:spLocks noGrp="1"/>
-          </p:cNvSpPr>
-          <p:nvPr>
-            <p:ph idx="1"/>
-          </p:nvPr>
-        </p:nvSpPr>
-        <p:spPr/>
-        <p:txBody>
-          <a:bodyPr/>
-          <a:lstStyle/>
-          <a:p>
-            <a:pPr lvl="0"/>
-            <a:r>
-              <a:rPr lang="en-US" smtClean="0"/>
-              <a:t>Click to edit Master text styles</a:t>
-            </a:r>
-          </a:p>
-          <a:p>
-            <a:pPr lvl="1"/>
-            <a:r>
-              <a:rPr lang="en-US" smtClean="0"/>
-              <a:t>Second level</a:t>
-            </a:r>
-          </a:p>
-          <a:p>
-            <a:pPr lvl="2"/>
-            <a:r>
-              <a:rPr lang="en-US" smtClean="0"/>
-              <a:t>Third level</a:t>
-            </a:r>
-          </a:p>
-          <a:p>
-            <a:pPr lvl="3"/>
-            <a:r>
-              <a:rPr lang="en-US" smtClean="0"/>
-              <a:t>Fourth level</a:t>
-            </a:r>
-          </a:p>
-          <a:p>
-            <a:pPr lvl="4"/>
-            <a:r>
-              <a:rPr lang="en-US" smtClean="0"/>
-              <a:t>Fifth level</a:t>
-            </a:r>
-            <a:endParaRPr lang="en-US"/>
-          </a:p>
-        </p:txBody>
-      </p:sp>
-      <p:sp>
-        <p:nvSpPr>
-          <p:cNvPr id="4" name="Date Placeholder 3"/>
-          <p:cNvSpPr>
-            <a:spLocks noGrp="1"/>
-          </p:cNvSpPr>
-          <p:nvPr>
-            <p:ph type="dt" sz="half" idx="10"/>
-          </p:nvPr>
-        </p:nvSpPr>
-        <p:spPr/>
-        <p:txBody>
-          <a:bodyPr/>
-          <a:lstStyle/>
-          <a:p>
-            <a:fld id="{5BCAD085-E8A6-8845-BD4E-CB4CCA059FC4}" type="datetimeFigureOut">
-              <a:rPr lang="en-US" smtClean="0"/>
-              <a:t>1/27/13</a:t>
-            </a:fld>
-            <a:endParaRPr lang="en-US"/>
-          </a:p>
-        </p:txBody>
-      </p:sp>
-      <p:sp>
-        <p:nvSpPr>
-          <p:cNvPr id="5" name="Footer Placeholder 4"/>
-          <p:cNvSpPr>
-            <a:spLocks noGrp="1"/>
-          </p:cNvSpPr>
-          <p:nvPr>
-            <p:ph type="ftr" sz="quarter" idx="11"/>
-          </p:nvPr>
-        </p:nvSpPr>
-        <p:spPr/>
-        <p:txBody>
-          <a:bodyPr/>
-          <a:lstStyle/>
-          <a:p>
-            <a:endParaRPr lang="en-US"/>
-          </a:p>
-        </p:txBody>
-      </p:sp>
-      <p:sp>
-        <p:nvSpPr>
-          <p:cNvPr id="6" name="Slide Number Placeholder 5"/>
-          <p:cNvSpPr>
-            <a:spLocks noGrp="1"/>
-          </p:cNvSpPr>
-          <p:nvPr>
-            <p:ph type="sldNum" sz="quarter" idx="12"/>
-          </p:nvPr>
-        </p:nvSpPr>
-        <p:spPr/>
-        <p:txBody>
-          <a:bodyPr/>
-          <a:lstStyle/>
-          <a:p>
-            <a:fld id="{C1FF6DA9-008F-8B48-92A6-B652298478BF}" type="slidenum">
-              <a:rPr lang="en-US" smtClean="0"/>
-              <a:t>‹#›</a:t>
-            </a:fld>
-            <a:endParaRPr lang="en-US"/>
-          </a:p>
-        </p:txBody>
-      </p:sp>
-    </p:spTree>
-    <p:extLst>
-      <p:ext uri="{BB962C8B-B14F-4D97-AF65-F5344CB8AC3E}">
-        <p14:creationId xmlns:p14="http://schemas.microsoft.com/office/powerpoint/2010/main" val="2614314258"/>
-      </p:ext>
-    </p:extLst>
-  </p:cSld>
-  <p:clrMapOvr>
-    <a:masterClrMapping/>
-  </p:clrMapOvr>
-</p:sldLayout>
-</file>
-
-<file path=ppt/slideLayouts/slideLayout3.xml><?xml version="1.0" encoding="utf-8"?>
-<p:sldLayout xmlns:a="http://schemas.openxmlformats.org/drawingml/2006/main" xmlns:r="http://schemas.openxmlformats.org/officeDocument/2006/relationships" xmlns:p="http://schemas.openxmlformats.org/presentationml/2006/main" type="secHead" preserve="1">
-  <p:cSld name="Section Header">
-    <p:spTree>
-      <p:nvGrpSpPr>
-        <p:cNvPr id="1" name=""/>
-        <p:cNvGrpSpPr/>
-        <p:nvPr/>
-      </p:nvGrpSpPr>
-      <p:grpSpPr>
-        <a:xfrm>
-          <a:off x="0" y="0"/>
-          <a:ext cx="0" cy="0"/>
-          <a:chOff x="0" y="0"/>
-          <a:chExt cx="0" cy="0"/>
-        </a:xfrm>
-      </p:grpSpPr>
-      <p:sp>
-        <p:nvSpPr>
-          <p:cNvPr id="2" name="Title 1"/>
-          <p:cNvSpPr>
-            <a:spLocks noGrp="1"/>
-          </p:cNvSpPr>
-          <p:nvPr>
-            <p:ph type="title"/>
-          </p:nvPr>
-        </p:nvSpPr>
-        <p:spPr>
-          <a:xfrm>
-            <a:off x="722313" y="4406900"/>
-            <a:ext cx="7772400" cy="1362075"/>
-          </a:xfrm>
-        </p:spPr>
-        <p:txBody>
-          <a:bodyPr anchor="t"/>
-          <a:lstStyle>
-            <a:lvl1pPr algn="l">
-              <a:defRPr sz="4000" b="1" cap="all"/>
-            </a:lvl1pPr>
-          </a:lstStyle>
-          <a:p>
-            <a:r>
-              <a:rPr lang="en-US" smtClean="0"/>
-              <a:t>Click to edit Master title style</a:t>
-            </a:r>
-            <a:endParaRPr lang="en-US"/>
-          </a:p>
-        </p:txBody>
-      </p:sp>
-      <p:sp>
-        <p:nvSpPr>
-          <p:cNvPr id="3" name="Text Placeholder 2"/>
-          <p:cNvSpPr>
-            <a:spLocks noGrp="1"/>
-          </p:cNvSpPr>
-          <p:nvPr>
-            <p:ph type="body" idx="1"/>
-          </p:nvPr>
-        </p:nvSpPr>
-        <p:spPr>
-          <a:xfrm>
-            <a:off x="722313" y="2906713"/>
-            <a:ext cx="7772400" cy="1500187"/>
-          </a:xfrm>
-        </p:spPr>
-        <p:txBody>
-          <a:bodyPr anchor="b"/>
-          <a:lstStyle>
-            <a:lvl1pPr marL="0" indent="0">
-              <a:buNone/>
-              <a:defRPr sz="2000">
-                <a:solidFill>
-                  <a:schemeClr val="tx1">
-                    <a:tint val="75000"/>
-                  </a:schemeClr>
-                </a:solidFill>
-              </a:defRPr>
-            </a:lvl1pPr>
-            <a:lvl2pPr marL="457200" indent="0">
-              <a:buNone/>
-              <a:defRPr sz="1800">
-                <a:solidFill>
-                  <a:schemeClr val="tx1">
-                    <a:tint val="75000"/>
-                  </a:schemeClr>
-                </a:solidFill>
-              </a:defRPr>
-            </a:lvl2pPr>
-            <a:lvl3pPr marL="914400" indent="0">
-              <a:buNone/>
-              <a:defRPr sz="1600">
-                <a:solidFill>
-                  <a:schemeClr val="tx1">
-                    <a:tint val="75000"/>
-                  </a:schemeClr>
-                </a:solidFill>
-              </a:defRPr>
-            </a:lvl3pPr>
-            <a:lvl4pPr marL="1371600" indent="0">
-              <a:buNone/>
-              <a:defRPr sz="1400">
-                <a:solidFill>
-                  <a:schemeClr val="tx1">
-                    <a:tint val="75000"/>
-                  </a:schemeClr>
-                </a:solidFill>
-              </a:defRPr>
-            </a:lvl4pPr>
-            <a:lvl5pPr marL="1828800" indent="0">
-              <a:buNone/>
-              <a:defRPr sz="1400">
-                <a:solidFill>
-                  <a:schemeClr val="tx1">
-                    <a:tint val="75000"/>
-                  </a:schemeClr>
-                </a:solidFill>
-              </a:defRPr>
-            </a:lvl5pPr>
-            <a:lvl6pPr marL="2286000" indent="0">
-              <a:buNone/>
-              <a:defRPr sz="1400">
-                <a:solidFill>
-                  <a:schemeClr val="tx1">
-                    <a:tint val="75000"/>
-                  </a:schemeClr>
-                </a:solidFill>
-              </a:defRPr>
-            </a:lvl6pPr>
-            <a:lvl7pPr marL="2743200" indent="0">
-              <a:buNone/>
-              <a:defRPr sz="1400">
-                <a:solidFill>
-                  <a:schemeClr val="tx1">
-                    <a:tint val="75000"/>
-                  </a:schemeClr>
-                </a:solidFill>
-              </a:defRPr>
-            </a:lvl7pPr>
-            <a:lvl8pPr marL="3200400" indent="0">
-              <a:buNone/>
-              <a:defRPr sz="1400">
-                <a:solidFill>
-                  <a:schemeClr val="tx1">
-                    <a:tint val="75000"/>
-                  </a:schemeClr>
-                </a:solidFill>
-              </a:defRPr>
-            </a:lvl8pPr>
-            <a:lvl9pPr marL="3657600" indent="0">
-              <a:buNone/>
-              <a:defRPr sz="1400">
-                <a:solidFill>
-                  <a:schemeClr val="tx1">
-                    <a:tint val="75000"/>
-                  </a:schemeClr>
-                </a:solidFill>
-              </a:defRPr>
-            </a:lvl9pPr>
-          </a:lstStyle>
-          <a:p>
-            <a:pPr lvl="0"/>
-            <a:r>
-              <a:rPr lang="en-US" smtClean="0"/>
-              <a:t>Click to edit Master text styles</a:t>
-            </a:r>
-          </a:p>
-        </p:txBody>
-      </p:sp>
-      <p:sp>
-        <p:nvSpPr>
-          <p:cNvPr id="4" name="Date Placeholder 3"/>
-          <p:cNvSpPr>
-            <a:spLocks noGrp="1"/>
-          </p:cNvSpPr>
-          <p:nvPr>
-            <p:ph type="dt" sz="half" idx="10"/>
-          </p:nvPr>
-        </p:nvSpPr>
-        <p:spPr/>
-        <p:txBody>
-          <a:bodyPr/>
-          <a:lstStyle/>
-          <a:p>
-            <a:fld id="{5BCAD085-E8A6-8845-BD4E-CB4CCA059FC4}" type="datetimeFigureOut">
-              <a:rPr lang="en-US" smtClean="0"/>
-              <a:t>1/27/13</a:t>
-            </a:fld>
-            <a:endParaRPr lang="en-US"/>
-          </a:p>
-        </p:txBody>
-      </p:sp>
-      <p:sp>
-        <p:nvSpPr>
-          <p:cNvPr id="5" name="Footer Placeholder 4"/>
-          <p:cNvSpPr>
-            <a:spLocks noGrp="1"/>
-          </p:cNvSpPr>
-          <p:nvPr>
-            <p:ph type="ftr" sz="quarter" idx="11"/>
-          </p:nvPr>
-        </p:nvSpPr>
-        <p:spPr/>
-        <p:txBody>
-          <a:bodyPr/>
-          <a:lstStyle/>
-          <a:p>
-            <a:endParaRPr lang="en-US"/>
-          </a:p>
-        </p:txBody>
-      </p:sp>
-      <p:sp>
-        <p:nvSpPr>
-          <p:cNvPr id="6" name="Slide Number Placeholder 5"/>
-          <p:cNvSpPr>
-            <a:spLocks noGrp="1"/>
-          </p:cNvSpPr>
-          <p:nvPr>
-            <p:ph type="sldNum" sz="quarter" idx="12"/>
-          </p:nvPr>
-        </p:nvSpPr>
-        <p:spPr/>
-        <p:txBody>
-          <a:bodyPr/>
-          <a:lstStyle/>
-          <a:p>
-            <a:fld id="{C1FF6DA9-008F-8B48-92A6-B652298478BF}" type="slidenum">
-              <a:rPr lang="en-US" smtClean="0"/>
-              <a:t>‹#›</a:t>
-            </a:fld>
-            <a:endParaRPr lang="en-US"/>
-          </a:p>
-        </p:txBody>
-      </p:sp>
-    </p:spTree>
-    <p:extLst>
-      <p:ext uri="{BB962C8B-B14F-4D97-AF65-F5344CB8AC3E}">
-        <p14:creationId xmlns:p14="http://schemas.microsoft.com/office/powerpoint/2010/main" val="960648375"/>
-      </p:ext>
-    </p:extLst>
-  </p:cSld>
-  <p:clrMapOvr>
-    <a:masterClrMapping/>
-  </p:clrMapOvr>
-</p:sldLayout>
-</file>
-
-<file path=ppt/slideLayouts/slideLayout4.xml><?xml version="1.0" encoding="utf-8"?>
-<p:sldLayout xmlns:a="http://schemas.openxmlformats.org/drawingml/2006/main" xmlns:r="http://schemas.openxmlformats.org/officeDocument/2006/relationships" xmlns:p="http://schemas.openxmlformats.org/presentationml/2006/main" type="twoObj" preserve="1">
-  <p:cSld name="Two Content">
-    <p:spTree>
-      <p:nvGrpSpPr>
-        <p:cNvPr id="1" name=""/>
-        <p:cNvGrpSpPr/>
-        <p:nvPr/>
-      </p:nvGrpSpPr>
-      <p:grpSpPr>
-        <a:xfrm>
-          <a:off x="0" y="0"/>
-          <a:ext cx="0" cy="0"/>
-          <a:chOff x="0" y="0"/>
-          <a:chExt cx="0" cy="0"/>
-        </a:xfrm>
-      </p:grpSpPr>
-      <p:sp>
-        <p:nvSpPr>
-          <p:cNvPr id="2" name="Title 1"/>
-          <p:cNvSpPr>
-            <a:spLocks noGrp="1"/>
-          </p:cNvSpPr>
-          <p:nvPr>
-            <p:ph type="title"/>
-          </p:nvPr>
-        </p:nvSpPr>
-        <p:spPr/>
-        <p:txBody>
-          <a:bodyPr/>
-          <a:lstStyle/>
-          <a:p>
-            <a:r>
-              <a:rPr lang="en-US" smtClean="0"/>
-              <a:t>Click to edit Master title style</a:t>
-            </a:r>
-            <a:endParaRPr lang="en-US"/>
-          </a:p>
-        </p:txBody>
-      </p:sp>
-      <p:sp>
-        <p:nvSpPr>
-          <p:cNvPr id="3" name="Content Placeholder 2"/>
-          <p:cNvSpPr>
-            <a:spLocks noGrp="1"/>
-          </p:cNvSpPr>
-          <p:nvPr>
-            <p:ph sz="half" idx="1"/>
-          </p:nvPr>
-        </p:nvSpPr>
-        <p:spPr>
-          <a:xfrm>
-            <a:off x="457200" y="1600200"/>
-            <a:ext cx="4038600" cy="4525963"/>
-          </a:xfrm>
-        </p:spPr>
-        <p:txBody>
-          <a:bodyPr/>
-          <a:lstStyle>
-            <a:lvl1pPr>
-              <a:defRPr sz="2800"/>
-            </a:lvl1pPr>
-            <a:lvl2pPr>
-              <a:defRPr sz="2400"/>
-            </a:lvl2pPr>
-            <a:lvl3pPr>
-              <a:defRPr sz="2000"/>
-            </a:lvl3pPr>
-            <a:lvl4pPr>
-              <a:defRPr sz="1800"/>
-            </a:lvl4pPr>
-            <a:lvl5pPr>
-              <a:defRPr sz="1800"/>
-            </a:lvl5pPr>
-            <a:lvl6pPr>
-              <a:defRPr sz="1800"/>
-            </a:lvl6pPr>
-            <a:lvl7pPr>
-              <a:defRPr sz="1800"/>
-            </a:lvl7pPr>
-            <a:lvl8pPr>
-              <a:defRPr sz="1800"/>
-            </a:lvl8pPr>
-            <a:lvl9pPr>
-              <a:defRPr sz="1800"/>
-            </a:lvl9pPr>
-          </a:lstStyle>
-          <a:p>
-            <a:pPr lvl="0"/>
-            <a:r>
-              <a:rPr lang="en-US" smtClean="0"/>
-              <a:t>Click to edit Master text styles</a:t>
-            </a:r>
-          </a:p>
-          <a:p>
-            <a:pPr lvl="1"/>
-            <a:r>
-              <a:rPr lang="en-US" smtClean="0"/>
-              <a:t>Second level</a:t>
-            </a:r>
-          </a:p>
-          <a:p>
-            <a:pPr lvl="2"/>
-            <a:r>
-              <a:rPr lang="en-US" smtClean="0"/>
-              <a:t>Third level</a:t>
-            </a:r>
-          </a:p>
-          <a:p>
-            <a:pPr lvl="3"/>
-            <a:r>
-              <a:rPr lang="en-US" smtClean="0"/>
-              <a:t>Fourth level</a:t>
-            </a:r>
-          </a:p>
-          <a:p>
-            <a:pPr lvl="4"/>
-            <a:r>
-              <a:rPr lang="en-US" smtClean="0"/>
-              <a:t>Fifth level</a:t>
-            </a:r>
-            <a:endParaRPr lang="en-US"/>
-          </a:p>
-        </p:txBody>
-      </p:sp>
-      <p:sp>
-        <p:nvSpPr>
-          <p:cNvPr id="4" name="Content Placeholder 3"/>
-          <p:cNvSpPr>
-            <a:spLocks noGrp="1"/>
-          </p:cNvSpPr>
-          <p:nvPr>
-            <p:ph sz="half" idx="2"/>
-          </p:nvPr>
-        </p:nvSpPr>
-        <p:spPr>
-          <a:xfrm>
-            <a:off x="4648200" y="1600200"/>
-            <a:ext cx="4038600" cy="4525963"/>
-          </a:xfrm>
-        </p:spPr>
-        <p:txBody>
-          <a:bodyPr/>
-          <a:lstStyle>
-            <a:lvl1pPr>
-              <a:defRPr sz="2800"/>
-            </a:lvl1pPr>
-            <a:lvl2pPr>
-              <a:defRPr sz="2400"/>
-            </a:lvl2pPr>
-            <a:lvl3pPr>
-              <a:defRPr sz="2000"/>
-            </a:lvl3pPr>
-            <a:lvl4pPr>
-              <a:defRPr sz="1800"/>
-            </a:lvl4pPr>
-            <a:lvl5pPr>
-              <a:defRPr sz="1800"/>
-            </a:lvl5pPr>
-            <a:lvl6pPr>
-              <a:defRPr sz="1800"/>
-            </a:lvl6pPr>
-            <a:lvl7pPr>
-              <a:defRPr sz="1800"/>
-            </a:lvl7pPr>
-            <a:lvl8pPr>
-              <a:defRPr sz="1800"/>
-            </a:lvl8pPr>
-            <a:lvl9pPr>
-              <a:defRPr sz="1800"/>
-            </a:lvl9pPr>
-          </a:lstStyle>
-          <a:p>
-            <a:pPr lvl="0"/>
-            <a:r>
-              <a:rPr lang="en-US" smtClean="0"/>
-              <a:t>Click to edit Master text styles</a:t>
-            </a:r>
-          </a:p>
-          <a:p>
-            <a:pPr lvl="1"/>
-            <a:r>
-              <a:rPr lang="en-US" smtClean="0"/>
-              <a:t>Second level</a:t>
-            </a:r>
-          </a:p>
-          <a:p>
-            <a:pPr lvl="2"/>
-            <a:r>
-              <a:rPr lang="en-US" smtClean="0"/>
-              <a:t>Third level</a:t>
-            </a:r>
-          </a:p>
-          <a:p>
-            <a:pPr lvl="3"/>
-            <a:r>
-              <a:rPr lang="en-US" smtClean="0"/>
-              <a:t>Fourth level</a:t>
-            </a:r>
-          </a:p>
-          <a:p>
-            <a:pPr lvl="4"/>
-            <a:r>
-              <a:rPr lang="en-US" smtClean="0"/>
-              <a:t>Fifth level</a:t>
-            </a:r>
-            <a:endParaRPr lang="en-US"/>
-          </a:p>
-        </p:txBody>
-      </p:sp>
-      <p:sp>
-        <p:nvSpPr>
-          <p:cNvPr id="5" name="Date Placeholder 4"/>
-          <p:cNvSpPr>
-            <a:spLocks noGrp="1"/>
-          </p:cNvSpPr>
-          <p:nvPr>
-            <p:ph type="dt" sz="half" idx="10"/>
-          </p:nvPr>
-        </p:nvSpPr>
-        <p:spPr/>
-        <p:txBody>
-          <a:bodyPr/>
-          <a:lstStyle/>
-          <a:p>
-            <a:fld id="{5BCAD085-E8A6-8845-BD4E-CB4CCA059FC4}" type="datetimeFigureOut">
-              <a:rPr lang="en-US" smtClean="0"/>
-              <a:t>1/27/13</a:t>
-            </a:fld>
-            <a:endParaRPr lang="en-US"/>
-          </a:p>
-        </p:txBody>
-      </p:sp>
-      <p:sp>
-        <p:nvSpPr>
-          <p:cNvPr id="6" name="Footer Placeholder 5"/>
-          <p:cNvSpPr>
-            <a:spLocks noGrp="1"/>
-          </p:cNvSpPr>
-          <p:nvPr>
-            <p:ph type="ftr" sz="quarter" idx="11"/>
-          </p:nvPr>
-        </p:nvSpPr>
-        <p:spPr/>
-        <p:txBody>
-          <a:bodyPr/>
-          <a:lstStyle/>
-          <a:p>
-            <a:endParaRPr lang="en-US"/>
-          </a:p>
-        </p:txBody>
-      </p:sp>
-      <p:sp>
-        <p:nvSpPr>
-          <p:cNvPr id="7" name="Slide Number Placeholder 6"/>
-          <p:cNvSpPr>
-            <a:spLocks noGrp="1"/>
-          </p:cNvSpPr>
-          <p:nvPr>
-            <p:ph type="sldNum" sz="quarter" idx="12"/>
-          </p:nvPr>
-        </p:nvSpPr>
-        <p:spPr/>
-        <p:txBody>
-          <a:bodyPr/>
-          <a:lstStyle/>
-          <a:p>
-            <a:fld id="{C1FF6DA9-008F-8B48-92A6-B652298478BF}" type="slidenum">
-              <a:rPr lang="en-US" smtClean="0"/>
-              <a:t>‹#›</a:t>
-            </a:fld>
-            <a:endParaRPr lang="en-US"/>
-          </a:p>
-        </p:txBody>
-      </p:sp>
-    </p:spTree>
-    <p:extLst>
-      <p:ext uri="{BB962C8B-B14F-4D97-AF65-F5344CB8AC3E}">
-        <p14:creationId xmlns:p14="http://schemas.microsoft.com/office/powerpoint/2010/main" val="2782244947"/>
-      </p:ext>
-    </p:extLst>
-  </p:cSld>
-  <p:clrMapOvr>
-    <a:masterClrMapping/>
-  </p:clrMapOvr>
-</p:sldLayout>
-</file>
-
-<file path=ppt/slideLayouts/slideLayout5.xml><?xml version="1.0" encoding="utf-8"?>
-<p:sldLayout xmlns:a="http://schemas.openxmlformats.org/drawingml/2006/main" xmlns:r="http://schemas.openxmlformats.org/officeDocument/2006/relationships" xmlns:p="http://schemas.openxmlformats.org/presentationml/2006/main" type="twoTxTwoObj" preserve="1">
-  <p:cSld name="Comparison">
-    <p:spTree>
-      <p:nvGrpSpPr>
-        <p:cNvPr id="1" name=""/>
-        <p:cNvGrpSpPr/>
-        <p:nvPr/>
-      </p:nvGrpSpPr>
-      <p:grpSpPr>
-        <a:xfrm>
-          <a:off x="0" y="0"/>
-          <a:ext cx="0" cy="0"/>
-          <a:chOff x="0" y="0"/>
-          <a:chExt cx="0" cy="0"/>
-        </a:xfrm>
-      </p:grpSpPr>
-      <p:sp>
-        <p:nvSpPr>
-          <p:cNvPr id="2" name="Title 1"/>
-          <p:cNvSpPr>
-            <a:spLocks noGrp="1"/>
-          </p:cNvSpPr>
-          <p:nvPr>
-            <p:ph type="title"/>
-          </p:nvPr>
-        </p:nvSpPr>
-        <p:spPr/>
-        <p:txBody>
-          <a:bodyPr/>
-          <a:lstStyle>
-            <a:lvl1pPr>
-              <a:defRPr/>
-            </a:lvl1pPr>
-          </a:lstStyle>
-          <a:p>
-            <a:r>
-              <a:rPr lang="en-US" smtClean="0"/>
-              <a:t>Click to edit Master title style</a:t>
-            </a:r>
-            <a:endParaRPr lang="en-US"/>
-          </a:p>
-        </p:txBody>
-      </p:sp>
-      <p:sp>
-        <p:nvSpPr>
-          <p:cNvPr id="3" name="Text Placeholder 2"/>
-          <p:cNvSpPr>
-            <a:spLocks noGrp="1"/>
-          </p:cNvSpPr>
-          <p:nvPr>
-            <p:ph type="body" idx="1"/>
-          </p:nvPr>
-        </p:nvSpPr>
-        <p:spPr>
-          <a:xfrm>
-            <a:off x="457200" y="1535113"/>
-            <a:ext cx="4040188" cy="639762"/>
-          </a:xfrm>
-        </p:spPr>
-        <p:txBody>
-          <a:bodyPr anchor="b"/>
-          <a:lstStyle>
-            <a:lvl1pPr marL="0" indent="0">
-              <a:buNone/>
-              <a:defRPr sz="2400" b="1"/>
-            </a:lvl1pPr>
-            <a:lvl2pPr marL="457200" indent="0">
-              <a:buNone/>
-              <a:defRPr sz="2000" b="1"/>
-            </a:lvl2pPr>
-            <a:lvl3pPr marL="914400" indent="0">
-              <a:buNone/>
-              <a:defRPr sz="1800" b="1"/>
-            </a:lvl3pPr>
-            <a:lvl4pPr marL="1371600" indent="0">
-              <a:buNone/>
-              <a:defRPr sz="1600" b="1"/>
-            </a:lvl4pPr>
-            <a:lvl5pPr marL="1828800" indent="0">
-              <a:buNone/>
-              <a:defRPr sz="1600" b="1"/>
-            </a:lvl5pPr>
-            <a:lvl6pPr marL="2286000" indent="0">
-              <a:buNone/>
-              <a:defRPr sz="1600" b="1"/>
-            </a:lvl6pPr>
-            <a:lvl7pPr marL="2743200" indent="0">
-              <a:buNone/>
-              <a:defRPr sz="1600" b="1"/>
-            </a:lvl7pPr>
-            <a:lvl8pPr marL="3200400" indent="0">
-              <a:buNone/>
-              <a:defRPr sz="1600" b="1"/>
-            </a:lvl8pPr>
-            <a:lvl9pPr marL="3657600" indent="0">
-              <a:buNone/>
-              <a:defRPr sz="1600" b="1"/>
-            </a:lvl9pPr>
-          </a:lstStyle>
-          <a:p>
-            <a:pPr lvl="0"/>
-            <a:r>
-              <a:rPr lang="en-US" smtClean="0"/>
-              <a:t>Click to edit Master text styles</a:t>
-            </a:r>
-          </a:p>
-        </p:txBody>
-      </p:sp>
-      <p:sp>
-        <p:nvSpPr>
-          <p:cNvPr id="4" name="Content Placeholder 3"/>
-          <p:cNvSpPr>
-            <a:spLocks noGrp="1"/>
-          </p:cNvSpPr>
-          <p:nvPr>
-            <p:ph sz="half" idx="2"/>
-          </p:nvPr>
-        </p:nvSpPr>
-        <p:spPr>
-          <a:xfrm>
-            <a:off x="457200" y="2174875"/>
-            <a:ext cx="4040188" cy="3951288"/>
-          </a:xfrm>
-        </p:spPr>
-        <p:txBody>
-          <a:bodyPr/>
-          <a:lstStyle>
-            <a:lvl1pPr>
-              <a:defRPr sz="2400"/>
-            </a:lvl1pPr>
-            <a:lvl2pPr>
-              <a:defRPr sz="2000"/>
-            </a:lvl2pPr>
-            <a:lvl3pPr>
-              <a:defRPr sz="1800"/>
-            </a:lvl3pPr>
-            <a:lvl4pPr>
-              <a:defRPr sz="1600"/>
-            </a:lvl4pPr>
-            <a:lvl5pPr>
-              <a:defRPr sz="1600"/>
-            </a:lvl5pPr>
-            <a:lvl6pPr>
-              <a:defRPr sz="1600"/>
-            </a:lvl6pPr>
-            <a:lvl7pPr>
-              <a:defRPr sz="1600"/>
-            </a:lvl7pPr>
-            <a:lvl8pPr>
-              <a:defRPr sz="1600"/>
-            </a:lvl8pPr>
-            <a:lvl9pPr>
-              <a:defRPr sz="1600"/>
-            </a:lvl9pPr>
-          </a:lstStyle>
-          <a:p>
-            <a:pPr lvl="0"/>
-            <a:r>
-              <a:rPr lang="en-US" smtClean="0"/>
-              <a:t>Click to edit Master text styles</a:t>
-            </a:r>
-          </a:p>
-          <a:p>
-            <a:pPr lvl="1"/>
-            <a:r>
-              <a:rPr lang="en-US" smtClean="0"/>
-              <a:t>Second level</a:t>
-            </a:r>
-          </a:p>
-          <a:p>
-            <a:pPr lvl="2"/>
-            <a:r>
-              <a:rPr lang="en-US" smtClean="0"/>
-              <a:t>Third level</a:t>
-            </a:r>
-          </a:p>
-          <a:p>
-            <a:pPr lvl="3"/>
-            <a:r>
-              <a:rPr lang="en-US" smtClean="0"/>
-              <a:t>Fourth level</a:t>
-            </a:r>
-          </a:p>
-          <a:p>
-            <a:pPr lvl="4"/>
-            <a:r>
-              <a:rPr lang="en-US" smtClean="0"/>
-              <a:t>Fifth level</a:t>
-            </a:r>
-            <a:endParaRPr lang="en-US"/>
-          </a:p>
-        </p:txBody>
-      </p:sp>
-      <p:sp>
-        <p:nvSpPr>
-          <p:cNvPr id="5" name="Text Placeholder 4"/>
-          <p:cNvSpPr>
-            <a:spLocks noGrp="1"/>
-          </p:cNvSpPr>
-          <p:nvPr>
-            <p:ph type="body" sz="quarter" idx="3"/>
-          </p:nvPr>
-        </p:nvSpPr>
-        <p:spPr>
-          <a:xfrm>
-            <a:off x="4645025" y="1535113"/>
-            <a:ext cx="4041775" cy="639762"/>
-          </a:xfrm>
-        </p:spPr>
-        <p:txBody>
-          <a:bodyPr anchor="b"/>
-          <a:lstStyle>
-            <a:lvl1pPr marL="0" indent="0">
-              <a:buNone/>
-              <a:defRPr sz="2400" b="1"/>
-            </a:lvl1pPr>
-            <a:lvl2pPr marL="457200" indent="0">
-              <a:buNone/>
-              <a:defRPr sz="2000" b="1"/>
-            </a:lvl2pPr>
-            <a:lvl3pPr marL="914400" indent="0">
-              <a:buNone/>
-              <a:defRPr sz="1800" b="1"/>
-            </a:lvl3pPr>
-            <a:lvl4pPr marL="1371600" indent="0">
-              <a:buNone/>
-              <a:defRPr sz="1600" b="1"/>
-            </a:lvl4pPr>
-            <a:lvl5pPr marL="1828800" indent="0">
-              <a:buNone/>
-              <a:defRPr sz="1600" b="1"/>
-            </a:lvl5pPr>
-            <a:lvl6pPr marL="2286000" indent="0">
-              <a:buNone/>
-              <a:defRPr sz="1600" b="1"/>
-            </a:lvl6pPr>
-            <a:lvl7pPr marL="2743200" indent="0">
-              <a:buNone/>
-              <a:defRPr sz="1600" b="1"/>
-            </a:lvl7pPr>
-            <a:lvl8pPr marL="3200400" indent="0">
-              <a:buNone/>
-              <a:defRPr sz="1600" b="1"/>
-            </a:lvl8pPr>
-            <a:lvl9pPr marL="3657600" indent="0">
-              <a:buNone/>
-              <a:defRPr sz="1600" b="1"/>
-            </a:lvl9pPr>
-          </a:lstStyle>
-          <a:p>
-            <a:pPr lvl="0"/>
-            <a:r>
-              <a:rPr lang="en-US" smtClean="0"/>
-              <a:t>Click to edit Master text styles</a:t>
-            </a:r>
-          </a:p>
-        </p:txBody>
-      </p:sp>
-      <p:sp>
-        <p:nvSpPr>
-          <p:cNvPr id="6" name="Content Placeholder 5"/>
-          <p:cNvSpPr>
-            <a:spLocks noGrp="1"/>
-          </p:cNvSpPr>
-          <p:nvPr>
-            <p:ph sz="quarter" idx="4"/>
-          </p:nvPr>
-        </p:nvSpPr>
-        <p:spPr>
-          <a:xfrm>
-            <a:off x="4645025" y="2174875"/>
-            <a:ext cx="4041775" cy="3951288"/>
-          </a:xfrm>
-        </p:spPr>
-        <p:txBody>
-          <a:bodyPr/>
-          <a:lstStyle>
-            <a:lvl1pPr>
-              <a:defRPr sz="2400"/>
-            </a:lvl1pPr>
-            <a:lvl2pPr>
-              <a:defRPr sz="2000"/>
-            </a:lvl2pPr>
-            <a:lvl3pPr>
-              <a:defRPr sz="1800"/>
-            </a:lvl3pPr>
-            <a:lvl4pPr>
-              <a:defRPr sz="1600"/>
-            </a:lvl4pPr>
-            <a:lvl5pPr>
-              <a:defRPr sz="1600"/>
-            </a:lvl5pPr>
-            <a:lvl6pPr>
-              <a:defRPr sz="1600"/>
-            </a:lvl6pPr>
-            <a:lvl7pPr>
-              <a:defRPr sz="1600"/>
-            </a:lvl7pPr>
-            <a:lvl8pPr>
-              <a:defRPr sz="1600"/>
-            </a:lvl8pPr>
-            <a:lvl9pPr>
-              <a:defRPr sz="1600"/>
-            </a:lvl9pPr>
-          </a:lstStyle>
-          <a:p>
-            <a:pPr lvl="0"/>
-            <a:r>
-              <a:rPr lang="en-US" smtClean="0"/>
-              <a:t>Click to edit Master text styles</a:t>
-            </a:r>
-          </a:p>
-          <a:p>
-            <a:pPr lvl="1"/>
-            <a:r>
-              <a:rPr lang="en-US" smtClean="0"/>
-              <a:t>Second level</a:t>
-            </a:r>
-          </a:p>
-          <a:p>
-            <a:pPr lvl="2"/>
-            <a:r>
-              <a:rPr lang="en-US" smtClean="0"/>
-              <a:t>Third level</a:t>
-            </a:r>
-          </a:p>
-          <a:p>
-            <a:pPr lvl="3"/>
-            <a:r>
-              <a:rPr lang="en-US" smtClean="0"/>
-              <a:t>Fourth level</a:t>
-            </a:r>
-          </a:p>
-          <a:p>
-            <a:pPr lvl="4"/>
-            <a:r>
-              <a:rPr lang="en-US" smtClean="0"/>
-              <a:t>Fifth level</a:t>
-            </a:r>
-            <a:endParaRPr lang="en-US"/>
-          </a:p>
-        </p:txBody>
-      </p:sp>
-      <p:sp>
-        <p:nvSpPr>
-          <p:cNvPr id="7" name="Date Placeholder 6"/>
-          <p:cNvSpPr>
-            <a:spLocks noGrp="1"/>
-          </p:cNvSpPr>
-          <p:nvPr>
-            <p:ph type="dt" sz="half" idx="10"/>
-          </p:nvPr>
-        </p:nvSpPr>
-        <p:spPr/>
-        <p:txBody>
-          <a:bodyPr/>
-          <a:lstStyle/>
-          <a:p>
-            <a:fld id="{5BCAD085-E8A6-8845-BD4E-CB4CCA059FC4}" type="datetimeFigureOut">
-              <a:rPr lang="en-US" smtClean="0"/>
-              <a:t>1/27/13</a:t>
-            </a:fld>
-            <a:endParaRPr lang="en-US"/>
-          </a:p>
-        </p:txBody>
-      </p:sp>
-      <p:sp>
-        <p:nvSpPr>
-          <p:cNvPr id="8" name="Footer Placeholder 7"/>
-          <p:cNvSpPr>
-            <a:spLocks noGrp="1"/>
-          </p:cNvSpPr>
-          <p:nvPr>
-            <p:ph type="ftr" sz="quarter" idx="11"/>
-          </p:nvPr>
-        </p:nvSpPr>
-        <p:spPr/>
-        <p:txBody>
-          <a:bodyPr/>
-          <a:lstStyle/>
-          <a:p>
-            <a:endParaRPr lang="en-US"/>
-          </a:p>
-        </p:txBody>
-      </p:sp>
-      <p:sp>
-        <p:nvSpPr>
-          <p:cNvPr id="9" name="Slide Number Placeholder 8"/>
-          <p:cNvSpPr>
-            <a:spLocks noGrp="1"/>
-          </p:cNvSpPr>
-          <p:nvPr>
-            <p:ph type="sldNum" sz="quarter" idx="12"/>
-          </p:nvPr>
-        </p:nvSpPr>
-        <p:spPr/>
-        <p:txBody>
-          <a:bodyPr/>
-          <a:lstStyle/>
-          <a:p>
-            <a:fld id="{C1FF6DA9-008F-8B48-92A6-B652298478BF}" type="slidenum">
-              <a:rPr lang="en-US" smtClean="0"/>
-              <a:t>‹#›</a:t>
-            </a:fld>
-            <a:endParaRPr lang="en-US"/>
-          </a:p>
-        </p:txBody>
-      </p:sp>
-    </p:spTree>
-    <p:extLst>
-      <p:ext uri="{BB962C8B-B14F-4D97-AF65-F5344CB8AC3E}">
-        <p14:creationId xmlns:p14="http://schemas.microsoft.com/office/powerpoint/2010/main" val="990158736"/>
-      </p:ext>
-    </p:extLst>
-  </p:cSld>
-  <p:clrMapOvr>
-    <a:masterClrMapping/>
-  </p:clrMapOvr>
-</p:sldLayout>
-</file>
-
-<file path=ppt/slideLayouts/slideLayout6.xml><?xml version="1.0" encoding="utf-8"?>
-<p:sldLayout xmlns:a="http://schemas.openxmlformats.org/drawingml/2006/main" xmlns:r="http://schemas.openxmlformats.org/officeDocument/2006/relationships" xmlns:p="http://schemas.openxmlformats.org/presentationml/2006/main" type="titleOnly" preserve="1">
-  <p:cSld name="Title Only">
-    <p:spTree>
-      <p:nvGrpSpPr>
-        <p:cNvPr id="1" name=""/>
-        <p:cNvGrpSpPr/>
-        <p:nvPr/>
-      </p:nvGrpSpPr>
-      <p:grpSpPr>
-        <a:xfrm>
-          <a:off x="0" y="0"/>
-          <a:ext cx="0" cy="0"/>
-          <a:chOff x="0" y="0"/>
-          <a:chExt cx="0" cy="0"/>
-        </a:xfrm>
-      </p:grpSpPr>
-      <p:sp>
-        <p:nvSpPr>
-          <p:cNvPr id="2" name="Title 1"/>
-          <p:cNvSpPr>
-            <a:spLocks noGrp="1"/>
-          </p:cNvSpPr>
-          <p:nvPr>
-            <p:ph type="title"/>
-          </p:nvPr>
-        </p:nvSpPr>
-        <p:spPr/>
-        <p:txBody>
-          <a:bodyPr/>
-          <a:lstStyle/>
-          <a:p>
-            <a:r>
-              <a:rPr lang="en-US" smtClean="0"/>
-              <a:t>Click to edit Master title style</a:t>
-            </a:r>
-            <a:endParaRPr lang="en-US"/>
-          </a:p>
-        </p:txBody>
-      </p:sp>
-      <p:sp>
-        <p:nvSpPr>
-          <p:cNvPr id="3" name="Date Placeholder 2"/>
-          <p:cNvSpPr>
-            <a:spLocks noGrp="1"/>
-          </p:cNvSpPr>
-          <p:nvPr>
-            <p:ph type="dt" sz="half" idx="10"/>
-          </p:nvPr>
-        </p:nvSpPr>
-        <p:spPr/>
-        <p:txBody>
-          <a:bodyPr/>
-          <a:lstStyle/>
-          <a:p>
-            <a:fld id="{5BCAD085-E8A6-8845-BD4E-CB4CCA059FC4}" type="datetimeFigureOut">
-              <a:rPr lang="en-US" smtClean="0"/>
-              <a:t>1/27/13</a:t>
-            </a:fld>
-            <a:endParaRPr lang="en-US"/>
-          </a:p>
-        </p:txBody>
-      </p:sp>
-      <p:sp>
-        <p:nvSpPr>
-          <p:cNvPr id="4" name="Footer Placeholder 3"/>
-          <p:cNvSpPr>
-            <a:spLocks noGrp="1"/>
-          </p:cNvSpPr>
-          <p:nvPr>
-            <p:ph type="ftr" sz="quarter" idx="11"/>
-          </p:nvPr>
-        </p:nvSpPr>
-        <p:spPr/>
-        <p:txBody>
-          <a:bodyPr/>
-          <a:lstStyle/>
-          <a:p>
-            <a:endParaRPr lang="en-US"/>
-          </a:p>
-        </p:txBody>
-      </p:sp>
-      <p:sp>
-        <p:nvSpPr>
-          <p:cNvPr id="5" name="Slide Number Placeholder 4"/>
-          <p:cNvSpPr>
-            <a:spLocks noGrp="1"/>
-          </p:cNvSpPr>
-          <p:nvPr>
-            <p:ph type="sldNum" sz="quarter" idx="12"/>
-          </p:nvPr>
-        </p:nvSpPr>
-        <p:spPr/>
-        <p:txBody>
-          <a:bodyPr/>
-          <a:lstStyle/>
-          <a:p>
-            <a:fld id="{C1FF6DA9-008F-8B48-92A6-B652298478BF}" type="slidenum">
-              <a:rPr lang="en-US" smtClean="0"/>
-              <a:t>‹#›</a:t>
-            </a:fld>
-            <a:endParaRPr lang="en-US"/>
-          </a:p>
-        </p:txBody>
-      </p:sp>
-    </p:spTree>
-    <p:extLst>
-      <p:ext uri="{BB962C8B-B14F-4D97-AF65-F5344CB8AC3E}">
-        <p14:creationId xmlns:p14="http://schemas.microsoft.com/office/powerpoint/2010/main" val="727027711"/>
-      </p:ext>
-    </p:extLst>
-  </p:cSld>
-  <p:clrMapOvr>
-    <a:masterClrMapping/>
-  </p:clrMapOvr>
-</p:sldLayout>
-</file>
-
-<file path=ppt/slideLayouts/slideLayout7.xml><?xml version="1.0" encoding="utf-8"?>
-<p:sldLayout xmlns:a="http://schemas.openxmlformats.org/drawingml/2006/main" xmlns:r="http://schemas.openxmlformats.org/officeDocument/2006/relationships" xmlns:p="http://schemas.openxmlformats.org/presentationml/2006/main" type="blank" preserve="1">
-  <p:cSld name="Blank">
-    <p:spTree>
-      <p:nvGrpSpPr>
-        <p:cNvPr id="1" name=""/>
-        <p:cNvGrpSpPr/>
-        <p:nvPr/>
-      </p:nvGrpSpPr>
-      <p:grpSpPr>
-        <a:xfrm>
-          <a:off x="0" y="0"/>
-          <a:ext cx="0" cy="0"/>
-          <a:chOff x="0" y="0"/>
-          <a:chExt cx="0" cy="0"/>
-        </a:xfrm>
-      </p:grpSpPr>
-      <p:sp>
-        <p:nvSpPr>
-          <p:cNvPr id="2" name="Date Placeholder 1"/>
-          <p:cNvSpPr>
-            <a:spLocks noGrp="1"/>
-          </p:cNvSpPr>
-          <p:nvPr>
-            <p:ph type="dt" sz="half" idx="10"/>
-          </p:nvPr>
-        </p:nvSpPr>
-        <p:spPr/>
-        <p:txBody>
-          <a:bodyPr/>
-          <a:lstStyle/>
-          <a:p>
-            <a:fld id="{5BCAD085-E8A6-8845-BD4E-CB4CCA059FC4}" type="datetimeFigureOut">
-              <a:rPr lang="en-US" smtClean="0"/>
-              <a:t>1/27/13</a:t>
-            </a:fld>
-            <a:endParaRPr lang="en-US"/>
-          </a:p>
-        </p:txBody>
-      </p:sp>
-      <p:sp>
-        <p:nvSpPr>
-          <p:cNvPr id="3" name="Footer Placeholder 2"/>
-          <p:cNvSpPr>
-            <a:spLocks noGrp="1"/>
-          </p:cNvSpPr>
-          <p:nvPr>
-            <p:ph type="ftr" sz="quarter" idx="11"/>
-          </p:nvPr>
-        </p:nvSpPr>
-        <p:spPr/>
-        <p:txBody>
-          <a:bodyPr/>
-          <a:lstStyle/>
-          <a:p>
-            <a:endParaRPr lang="en-US"/>
-          </a:p>
-        </p:txBody>
-      </p:sp>
-      <p:sp>
-        <p:nvSpPr>
-          <p:cNvPr id="4" name="Slide Number Placeholder 3"/>
-          <p:cNvSpPr>
-            <a:spLocks noGrp="1"/>
-          </p:cNvSpPr>
-          <p:nvPr>
-            <p:ph type="sldNum" sz="quarter" idx="12"/>
-          </p:nvPr>
-        </p:nvSpPr>
-        <p:spPr/>
-        <p:txBody>
-          <a:bodyPr/>
-          <a:lstStyle/>
-          <a:p>
-            <a:fld id="{C1FF6DA9-008F-8B48-92A6-B652298478BF}" type="slidenum">
-              <a:rPr lang="en-US" smtClean="0"/>
-              <a:t>‹#›</a:t>
-            </a:fld>
-            <a:endParaRPr lang="en-US"/>
-          </a:p>
-        </p:txBody>
-      </p:sp>
-    </p:spTree>
-    <p:extLst>
-      <p:ext uri="{BB962C8B-B14F-4D97-AF65-F5344CB8AC3E}">
-        <p14:creationId xmlns:p14="http://schemas.microsoft.com/office/powerpoint/2010/main" val="1212999818"/>
-      </p:ext>
-    </p:extLst>
-  </p:cSld>
-  <p:clrMapOvr>
-    <a:masterClrMapping/>
-  </p:clrMapOvr>
-</p:sldLayout>
-</file>
-
-<file path=ppt/slideLayouts/slideLayout8.xml><?xml version="1.0" encoding="utf-8"?>
-<p:sldLayout xmlns:a="http://schemas.openxmlformats.org/drawingml/2006/main" xmlns:r="http://schemas.openxmlformats.org/officeDocument/2006/relationships" xmlns:p="http://schemas.openxmlformats.org/presentationml/2006/main" type="objTx" preserve="1">
-  <p:cSld name="Content with Caption">
-    <p:spTree>
-      <p:nvGrpSpPr>
-        <p:cNvPr id="1" name=""/>
-        <p:cNvGrpSpPr/>
-        <p:nvPr/>
-      </p:nvGrpSpPr>
-      <p:grpSpPr>
-        <a:xfrm>
-          <a:off x="0" y="0"/>
-          <a:ext cx="0" cy="0"/>
-          <a:chOff x="0" y="0"/>
-          <a:chExt cx="0" cy="0"/>
-        </a:xfrm>
-      </p:grpSpPr>
-      <p:sp>
-        <p:nvSpPr>
-          <p:cNvPr id="2" name="Title 1"/>
-          <p:cNvSpPr>
-            <a:spLocks noGrp="1"/>
-          </p:cNvSpPr>
-          <p:nvPr>
-            <p:ph type="title"/>
-          </p:nvPr>
-        </p:nvSpPr>
-        <p:spPr>
-          <a:xfrm>
-            <a:off x="457200" y="273050"/>
-            <a:ext cx="3008313" cy="1162050"/>
-          </a:xfrm>
-        </p:spPr>
-        <p:txBody>
-          <a:bodyPr anchor="b"/>
-          <a:lstStyle>
-            <a:lvl1pPr algn="l">
-              <a:defRPr sz="2000" b="1"/>
-            </a:lvl1pPr>
-          </a:lstStyle>
-          <a:p>
-            <a:r>
-              <a:rPr lang="en-US" smtClean="0"/>
-              <a:t>Click to edit Master title style</a:t>
-            </a:r>
-            <a:endParaRPr lang="en-US"/>
-          </a:p>
-        </p:txBody>
-      </p:sp>
-      <p:sp>
-        <p:nvSpPr>
-          <p:cNvPr id="3" name="Content Placeholder 2"/>
-          <p:cNvSpPr>
-            <a:spLocks noGrp="1"/>
-          </p:cNvSpPr>
-          <p:nvPr>
-            <p:ph idx="1"/>
-          </p:nvPr>
-        </p:nvSpPr>
-        <p:spPr>
-          <a:xfrm>
-            <a:off x="3575050" y="273050"/>
-            <a:ext cx="5111750" cy="5853113"/>
-          </a:xfrm>
-        </p:spPr>
-        <p:txBody>
-          <a:bodyPr/>
-          <a:lstStyle>
-            <a:lvl1pPr>
-              <a:defRPr sz="3200"/>
-            </a:lvl1pPr>
-            <a:lvl2pPr>
-              <a:defRPr sz="2800"/>
-            </a:lvl2pPr>
-            <a:lvl3pPr>
-              <a:defRPr sz="2400"/>
-            </a:lvl3pPr>
-            <a:lvl4pPr>
-              <a:defRPr sz="2000"/>
-            </a:lvl4pPr>
-            <a:lvl5pPr>
-              <a:defRPr sz="2000"/>
-            </a:lvl5pPr>
-            <a:lvl6pPr>
-              <a:defRPr sz="2000"/>
-            </a:lvl6pPr>
-            <a:lvl7pPr>
-              <a:defRPr sz="2000"/>
-            </a:lvl7pPr>
-            <a:lvl8pPr>
-              <a:defRPr sz="2000"/>
-            </a:lvl8pPr>
-            <a:lvl9pPr>
-              <a:defRPr sz="2000"/>
-            </a:lvl9pPr>
-          </a:lstStyle>
-          <a:p>
-            <a:pPr lvl="0"/>
-            <a:r>
-              <a:rPr lang="en-US" smtClean="0"/>
-              <a:t>Click to edit Master text styles</a:t>
-            </a:r>
-          </a:p>
-          <a:p>
-            <a:pPr lvl="1"/>
-            <a:r>
-              <a:rPr lang="en-US" smtClean="0"/>
-              <a:t>Second level</a:t>
-            </a:r>
-          </a:p>
-          <a:p>
-            <a:pPr lvl="2"/>
-            <a:r>
-              <a:rPr lang="en-US" smtClean="0"/>
-              <a:t>Third level</a:t>
-            </a:r>
-          </a:p>
-          <a:p>
-            <a:pPr lvl="3"/>
-            <a:r>
-              <a:rPr lang="en-US" smtClean="0"/>
-              <a:t>Fourth level</a:t>
-            </a:r>
-          </a:p>
-          <a:p>
-            <a:pPr lvl="4"/>
-            <a:r>
-              <a:rPr lang="en-US" smtClean="0"/>
-              <a:t>Fifth level</a:t>
-            </a:r>
-            <a:endParaRPr lang="en-US"/>
-          </a:p>
-        </p:txBody>
-      </p:sp>
-      <p:sp>
-        <p:nvSpPr>
-          <p:cNvPr id="4" name="Text Placeholder 3"/>
-          <p:cNvSpPr>
-            <a:spLocks noGrp="1"/>
-          </p:cNvSpPr>
-          <p:nvPr>
-            <p:ph type="body" sz="half" idx="2"/>
-          </p:nvPr>
-        </p:nvSpPr>
-        <p:spPr>
-          <a:xfrm>
-            <a:off x="457200" y="1435100"/>
-            <a:ext cx="3008313" cy="4691063"/>
-          </a:xfrm>
-        </p:spPr>
-        <p:txBody>
-          <a:bodyPr/>
-          <a:lstStyle>
-            <a:lvl1pPr marL="0" indent="0">
-              <a:buNone/>
-              <a:defRPr sz="1400"/>
-            </a:lvl1pPr>
-            <a:lvl2pPr marL="457200" indent="0">
-              <a:buNone/>
-              <a:defRPr sz="1200"/>
-            </a:lvl2pPr>
-            <a:lvl3pPr marL="914400" indent="0">
-              <a:buNone/>
-              <a:defRPr sz="1000"/>
-            </a:lvl3pPr>
-            <a:lvl4pPr marL="1371600" indent="0">
-              <a:buNone/>
-              <a:defRPr sz="900"/>
-            </a:lvl4pPr>
-            <a:lvl5pPr marL="1828800" indent="0">
-              <a:buNone/>
-              <a:defRPr sz="900"/>
-            </a:lvl5pPr>
-            <a:lvl6pPr marL="2286000" indent="0">
-              <a:buNone/>
-              <a:defRPr sz="900"/>
-            </a:lvl6pPr>
-            <a:lvl7pPr marL="2743200" indent="0">
-              <a:buNone/>
-              <a:defRPr sz="900"/>
-            </a:lvl7pPr>
-            <a:lvl8pPr marL="3200400" indent="0">
-              <a:buNone/>
-              <a:defRPr sz="900"/>
-            </a:lvl8pPr>
-            <a:lvl9pPr marL="3657600" indent="0">
-              <a:buNone/>
-              <a:defRPr sz="900"/>
-            </a:lvl9pPr>
-          </a:lstStyle>
-          <a:p>
-            <a:pPr lvl="0"/>
-            <a:r>
-              <a:rPr lang="en-US" smtClean="0"/>
-              <a:t>Click to edit Master text styles</a:t>
-            </a:r>
-          </a:p>
-        </p:txBody>
-      </p:sp>
-      <p:sp>
-        <p:nvSpPr>
-          <p:cNvPr id="5" name="Date Placeholder 4"/>
-          <p:cNvSpPr>
-            <a:spLocks noGrp="1"/>
-          </p:cNvSpPr>
-          <p:nvPr>
-            <p:ph type="dt" sz="half" idx="10"/>
-          </p:nvPr>
-        </p:nvSpPr>
-        <p:spPr/>
-        <p:txBody>
-          <a:bodyPr/>
-          <a:lstStyle/>
-          <a:p>
-            <a:fld id="{5BCAD085-E8A6-8845-BD4E-CB4CCA059FC4}" type="datetimeFigureOut">
-              <a:rPr lang="en-US" smtClean="0"/>
-              <a:t>1/27/13</a:t>
-            </a:fld>
-            <a:endParaRPr lang="en-US"/>
-          </a:p>
-        </p:txBody>
-      </p:sp>
-      <p:sp>
-        <p:nvSpPr>
-          <p:cNvPr id="6" name="Footer Placeholder 5"/>
-          <p:cNvSpPr>
-            <a:spLocks noGrp="1"/>
-          </p:cNvSpPr>
-          <p:nvPr>
-            <p:ph type="ftr" sz="quarter" idx="11"/>
-          </p:nvPr>
-        </p:nvSpPr>
-        <p:spPr/>
-        <p:txBody>
-          <a:bodyPr/>
-          <a:lstStyle/>
-          <a:p>
-            <a:endParaRPr lang="en-US"/>
-          </a:p>
-        </p:txBody>
-      </p:sp>
-      <p:sp>
-        <p:nvSpPr>
-          <p:cNvPr id="7" name="Slide Number Placeholder 6"/>
-          <p:cNvSpPr>
-            <a:spLocks noGrp="1"/>
-          </p:cNvSpPr>
-          <p:nvPr>
-            <p:ph type="sldNum" sz="quarter" idx="12"/>
-          </p:nvPr>
-        </p:nvSpPr>
-        <p:spPr/>
-        <p:txBody>
-          <a:bodyPr/>
-          <a:lstStyle/>
-          <a:p>
-            <a:fld id="{C1FF6DA9-008F-8B48-92A6-B652298478BF}" type="slidenum">
-              <a:rPr lang="en-US" smtClean="0"/>
-              <a:t>‹#›</a:t>
-            </a:fld>
-            <a:endParaRPr lang="en-US"/>
-          </a:p>
-        </p:txBody>
-      </p:sp>
-    </p:spTree>
-    <p:extLst>
-      <p:ext uri="{BB962C8B-B14F-4D97-AF65-F5344CB8AC3E}">
-        <p14:creationId xmlns:p14="http://schemas.microsoft.com/office/powerpoint/2010/main" val="1840726560"/>
-      </p:ext>
-    </p:extLst>
-  </p:cSld>
-  <p:clrMapOvr>
-    <a:masterClrMapping/>
-  </p:clrMapOvr>
-</p:sldLayout>
-</file>
-
-<file path=ppt/slideLayouts/slideLayout9.xml><?xml version="1.0" encoding="utf-8"?>
-<p:sldLayout xmlns:a="http://schemas.openxmlformats.org/drawingml/2006/main" xmlns:r="http://schemas.openxmlformats.org/officeDocument/2006/relationships" xmlns:p="http://schemas.openxmlformats.org/presentationml/2006/main" type="picTx" preserve="1">
-  <p:cSld name="Picture with Caption">
-    <p:spTree>
-      <p:nvGrpSpPr>
-        <p:cNvPr id="1" name=""/>
-        <p:cNvGrpSpPr/>
-        <p:nvPr/>
-      </p:nvGrpSpPr>
-      <p:grpSpPr>
-        <a:xfrm>
-          <a:off x="0" y="0"/>
-          <a:ext cx="0" cy="0"/>
-          <a:chOff x="0" y="0"/>
-          <a:chExt cx="0" cy="0"/>
-        </a:xfrm>
-      </p:grpSpPr>
-      <p:sp>
-        <p:nvSpPr>
-          <p:cNvPr id="2" name="Title 1"/>
-          <p:cNvSpPr>
-            <a:spLocks noGrp="1"/>
-          </p:cNvSpPr>
-          <p:nvPr>
-            <p:ph type="title"/>
-          </p:nvPr>
-        </p:nvSpPr>
-        <p:spPr>
-          <a:xfrm>
-            <a:off x="1792288" y="4800600"/>
-            <a:ext cx="5486400" cy="566738"/>
-          </a:xfrm>
-        </p:spPr>
-        <p:txBody>
-          <a:bodyPr anchor="b"/>
+        <p:spPr>
+          <a:xfrm>
+            <a:off x="548640" y="731520"/>
+            <a:ext cx="11091672" cy="1005840"/>
+          </a:xfrm>
+        </p:spPr>
+        <p:txBody>
+          <a:bodyPr anchor="t" wrap="square"/>
           <a:lstStyle>
             <a:lvl1pPr algn="l">
               <a:defRPr sz="2000" b="1"/>
@@ -3949,12 +2314,12 @@
         </p:nvSpPr>
         <p:spPr>
           <a:xfrm>
-            <a:off x="1792288" y="612775"/>
-            <a:ext cx="5486400" cy="4114800"/>
-          </a:xfrm>
-        </p:spPr>
-        <p:txBody>
-          <a:bodyPr/>
+            <a:off x="548640" y="1828800"/>
+            <a:ext cx="11091672" cy="3977639"/>
+          </a:xfrm>
+        </p:spPr>
+        <p:txBody>
+          <a:bodyPr wrap="square" anchor="ctr"/>
           <a:lstStyle>
             <a:lvl1pPr marL="0" indent="0">
               <a:buNone/>
@@ -4010,121 +2375,68 @@
         </p:nvSpPr>
         <p:spPr>
           <a:xfrm>
-            <a:off x="1792288" y="5367338"/>
-            <a:ext cx="5486400" cy="804862"/>
-          </a:xfrm>
-        </p:spPr>
-        <p:txBody>
-          <a:bodyPr/>
+            <a:off x="548640" y="5943600"/>
+            <a:ext cx="11091672" cy="457200"/>
+          </a:xfrm>
+        </p:spPr>
+        <p:txBody>
+          <a:bodyPr wrap="square" anchor="t"/>
           <a:lstStyle>
-            <a:lvl1pPr marL="0" indent="0">
+            <a:lvl1pPr marL="0" indent="0" algn="ctr">
               <a:buNone/>
-              <a:defRPr sz="1400"/>
+              <a:defRPr sz="1300">
+                <a:solidFill>
+                  <a:schemeClr val="accent4"/>
+                </a:solidFill>
+                <a:latin typeface="+mn-lt"/>
+              </a:defRPr>
             </a:lvl1pPr>
-            <a:lvl2pPr marL="457200" indent="0">
-              <a:buNone/>
-              <a:defRPr sz="1200"/>
-            </a:lvl2pPr>
-            <a:lvl3pPr marL="914400" indent="0">
-              <a:buNone/>
-              <a:defRPr sz="1000"/>
-            </a:lvl3pPr>
-            <a:lvl4pPr marL="1371600" indent="0">
-              <a:buNone/>
-              <a:defRPr sz="900"/>
-            </a:lvl4pPr>
-            <a:lvl5pPr marL="1828800" indent="0">
-              <a:buNone/>
-              <a:defRPr sz="900"/>
-            </a:lvl5pPr>
-            <a:lvl6pPr marL="2286000" indent="0">
-              <a:buNone/>
-              <a:defRPr sz="900"/>
-            </a:lvl6pPr>
-            <a:lvl7pPr marL="2743200" indent="0">
-              <a:buNone/>
-              <a:defRPr sz="900"/>
-            </a:lvl7pPr>
-            <a:lvl8pPr marL="3200400" indent="0">
-              <a:buNone/>
-              <a:defRPr sz="900"/>
-            </a:lvl8pPr>
-            <a:lvl9pPr marL="3657600" indent="0">
-              <a:buNone/>
-              <a:defRPr sz="900"/>
-            </a:lvl9pPr>
           </a:lstStyle>
           <a:p>
-            <a:pPr lvl="0"/>
-            <a:r>
-              <a:rPr lang="en-US" smtClean="0"/>
-              <a:t>Click to edit Master text styles</a:t>
-            </a:r>
-          </a:p>
-        </p:txBody>
-      </p:sp>
-      <p:sp>
-        <p:nvSpPr>
-          <p:cNvPr id="5" name="Date Placeholder 4"/>
+            <a:r>
+              <a:rPr lang="en-US"/>
+              <a:t>Source · license — click to add caption</a:t>
+            </a:r>
+          </a:p>
+        </p:txBody>
+      </p:sp>
+      <p:sp>
+        <p:nvSpPr>
+          <p:cNvPr id="5" name="Eyebrow Placeholder"/>
           <p:cNvSpPr>
             <a:spLocks noGrp="1"/>
           </p:cNvSpPr>
           <p:nvPr>
-            <p:ph type="dt" sz="half" idx="10"/>
+            <p:ph type="body" sz="quarter" idx="13"/>
           </p:nvPr>
         </p:nvSpPr>
-        <p:spPr/>
-        <p:txBody>
-          <a:bodyPr/>
-          <a:lstStyle/>
-          <a:p>
-            <a:fld id="{5BCAD085-E8A6-8845-BD4E-CB4CCA059FC4}" type="datetimeFigureOut">
-              <a:rPr lang="en-US" smtClean="0"/>
-              <a:t>1/27/13</a:t>
-            </a:fld>
-            <a:endParaRPr lang="en-US"/>
-          </a:p>
-        </p:txBody>
-      </p:sp>
-      <p:sp>
-        <p:nvSpPr>
-          <p:cNvPr id="6" name="Footer Placeholder 5"/>
-          <p:cNvSpPr>
-            <a:spLocks noGrp="1"/>
-          </p:cNvSpPr>
-          <p:nvPr>
-            <p:ph type="ftr" sz="quarter" idx="11"/>
-          </p:nvPr>
-        </p:nvSpPr>
-        <p:spPr/>
-        <p:txBody>
-          <a:bodyPr/>
-          <a:lstStyle/>
-          <a:p>
-            <a:endParaRPr lang="en-US"/>
-          </a:p>
-        </p:txBody>
-      </p:sp>
-      <p:sp>
-        <p:nvSpPr>
-          <p:cNvPr id="7" name="Slide Number Placeholder 6"/>
-          <p:cNvSpPr>
-            <a:spLocks noGrp="1"/>
-          </p:cNvSpPr>
-          <p:nvPr>
-            <p:ph type="sldNum" sz="quarter" idx="12"/>
-          </p:nvPr>
-        </p:nvSpPr>
-        <p:spPr/>
-        <p:txBody>
-          <a:bodyPr/>
-          <a:lstStyle/>
-          <a:p>
-            <a:fld id="{C1FF6DA9-008F-8B48-92A6-B652298478BF}" type="slidenum">
-              <a:rPr lang="en-US" smtClean="0"/>
-              <a:t>‹#›</a:t>
-            </a:fld>
-            <a:endParaRPr lang="en-US"/>
+        <p:spPr>
+          <a:xfrm>
+            <a:off x="548640" y="320040"/>
+            <a:ext cx="11091672" cy="365760"/>
+          </a:xfrm>
+          <a:prstGeom prst="rect">
+            <a:avLst/>
+          </a:prstGeom>
+        </p:spPr>
+        <p:txBody>
+          <a:bodyPr wrap="square" anchor="t"/>
+          <a:lstStyle>
+            <a:lvl1pPr marL="0" indent="0">
+              <a:buNone/>
+              <a:defRPr sz="1300" b="1" cap="all">
+                <a:solidFill>
+                  <a:schemeClr val="accent4"/>
+                </a:solidFill>
+                <a:latin typeface="Menlo"/>
+              </a:defRPr>
+            </a:lvl1pPr>
+          </a:lstStyle>
+          <a:p>
+            <a:r>
+              <a:rPr lang="en-US"/>
+              <a:t>MSACL · DS301 Deep Learning · Segment n · Lecture n</a:t>
+            </a:r>
           </a:p>
         </p:txBody>
       </p:sp>
@@ -4141,13 +2453,144 @@
 </p:sldLayout>
 </file>
 
-<file path=ppt/slideMasters/slideMaster1.xml><?xml version="1.0" encoding="utf-8"?>
+<file path=ppt/slideLayouts/slideLayout22.xml><?xml version="1.0" encoding="utf-8"?>
+<p:sldLayout xmlns:a="http://schemas.openxmlformats.org/drawingml/2006/main" xmlns:r="http://schemas.openxmlformats.org/officeDocument/2006/relationships" xmlns:p="http://schemas.openxmlformats.org/presentationml/2006/main" type="titleOnly" preserve="1">
+  <p:cSld name="Title Only">
+    <p:spTree>
+      <p:nvGrpSpPr>
+        <p:cNvPr id="1" name=""/>
+        <p:cNvGrpSpPr/>
+        <p:nvPr/>
+      </p:nvGrpSpPr>
+      <p:grpSpPr>
+        <a:xfrm>
+          <a:off x="0" y="0"/>
+          <a:ext cx="0" cy="0"/>
+          <a:chOff x="0" y="0"/>
+          <a:chExt cx="0" cy="0"/>
+        </a:xfrm>
+      </p:grpSpPr>
+      <p:sp>
+        <p:nvSpPr>
+          <p:cNvPr id="2" name="Title 1"/>
+          <p:cNvSpPr>
+            <a:spLocks noGrp="1"/>
+          </p:cNvSpPr>
+          <p:nvPr>
+            <p:ph type="title"/>
+          </p:nvPr>
+        </p:nvSpPr>
+        <p:spPr>
+          <a:xfrm>
+            <a:off x="548640" y="731520"/>
+            <a:ext cx="11091672" cy="1005840"/>
+          </a:xfrm>
+        </p:spPr>
+        <p:txBody>
+          <a:bodyPr wrap="square" anchor="t"/>
+          <a:lstStyle/>
+          <a:p>
+            <a:r>
+              <a:rPr lang="en-US" smtClean="0"/>
+              <a:t>Click to edit Master title style</a:t>
+            </a:r>
+            <a:endParaRPr lang="en-US"/>
+          </a:p>
+        </p:txBody>
+      </p:sp>
+      <p:sp>
+        <p:nvSpPr>
+          <p:cNvPr id="3" name="Eyebrow Placeholder"/>
+          <p:cNvSpPr>
+            <a:spLocks noGrp="1"/>
+          </p:cNvSpPr>
+          <p:nvPr>
+            <p:ph type="body" sz="quarter" idx="13"/>
+          </p:nvPr>
+        </p:nvSpPr>
+        <p:spPr>
+          <a:xfrm>
+            <a:off x="548640" y="320040"/>
+            <a:ext cx="11091672" cy="365760"/>
+          </a:xfrm>
+          <a:prstGeom prst="rect">
+            <a:avLst/>
+          </a:prstGeom>
+        </p:spPr>
+        <p:txBody>
+          <a:bodyPr wrap="square" anchor="t"/>
+          <a:lstStyle>
+            <a:lvl1pPr marL="0" indent="0">
+              <a:buNone/>
+              <a:defRPr sz="1300" b="1" cap="all">
+                <a:solidFill>
+                  <a:schemeClr val="accent4"/>
+                </a:solidFill>
+                <a:latin typeface="Menlo"/>
+              </a:defRPr>
+            </a:lvl1pPr>
+          </a:lstStyle>
+          <a:p>
+            <a:r>
+              <a:rPr lang="en-US"/>
+              <a:t>MSACL · DS301 Deep Learning · Segment n · Lecture n</a:t>
+            </a:r>
+          </a:p>
+        </p:txBody>
+      </p:sp>
+    </p:spTree>
+    <p:extLst>
+      <p:ext uri="{BB962C8B-B14F-4D97-AF65-F5344CB8AC3E}">
+        <p14:creationId xmlns:p14="http://schemas.microsoft.com/office/powerpoint/2010/main" val="727027711"/>
+      </p:ext>
+    </p:extLst>
+  </p:cSld>
+  <p:clrMapOvr>
+    <a:masterClrMapping/>
+  </p:clrMapOvr>
+</p:sldLayout>
+</file>
+
+<file path=ppt/slideLayouts/slideLayout23.xml><?xml version="1.0" encoding="utf-8"?>
+<p:sldLayout xmlns:a="http://schemas.openxmlformats.org/drawingml/2006/main" xmlns:r="http://schemas.openxmlformats.org/officeDocument/2006/relationships" xmlns:p="http://schemas.openxmlformats.org/presentationml/2006/main" type="blank" preserve="1">
+  <p:cSld name="Blank">
+    <p:spTree>
+      <p:nvGrpSpPr>
+        <p:cNvPr id="1" name=""/>
+        <p:cNvGrpSpPr/>
+        <p:nvPr/>
+      </p:nvGrpSpPr>
+      <p:grpSpPr>
+        <a:xfrm>
+          <a:off x="0" y="0"/>
+          <a:ext cx="0" cy="0"/>
+          <a:chOff x="0" y="0"/>
+          <a:chExt cx="0" cy="0"/>
+        </a:xfrm>
+      </p:grpSpPr>
+    </p:spTree>
+    <p:extLst>
+      <p:ext uri="{BB962C8B-B14F-4D97-AF65-F5344CB8AC3E}">
+        <p14:creationId xmlns:p14="http://schemas.microsoft.com/office/powerpoint/2010/main" val="1212999818"/>
+      </p:ext>
+    </p:extLst>
+  </p:cSld>
+  <p:clrMapOvr>
+    <a:masterClrMapping/>
+  </p:clrMapOvr>
+</p:sldLayout>
+</file>
+
+<file path=ppt/slideMasters/slideMaster3.xml><?xml version="1.0" encoding="utf-8"?>
 <p:sldMaster xmlns:a="http://schemas.openxmlformats.org/drawingml/2006/main" xmlns:r="http://schemas.openxmlformats.org/officeDocument/2006/relationships" xmlns:p="http://schemas.openxmlformats.org/presentationml/2006/main">
-  <p:cSld>
+  <p:cSld name="MSACL DS301">
     <p:bg>
-      <p:bgRef idx="1001">
-        <a:schemeClr val="bg1"/>
-      </p:bgRef>
+      <p:bgPr>
+        <a:solidFill>
+          <a:schemeClr val="bg1"/>
+        </a:solidFill>
+        <a:effectLst/>
+      </p:bgPr>
     </p:bg>
     <p:spTree>
       <p:nvGrpSpPr>
@@ -4175,15 +2618,15 @@
         </p:nvSpPr>
         <p:spPr>
           <a:xfrm>
-            <a:off x="457200" y="274638"/>
-            <a:ext cx="8229600" cy="1143000"/>
-          </a:xfrm>
-          <a:prstGeom prst="rect">
-            <a:avLst/>
-          </a:prstGeom>
-        </p:spPr>
-        <p:txBody>
-          <a:bodyPr vert="horz" lIns="91440" tIns="45720" rIns="91440" bIns="45720" rtlCol="0" anchor="ctr">
+            <a:off x="548640" y="731520"/>
+            <a:ext cx="11091672" cy="1005840"/>
+          </a:xfrm>
+          <a:prstGeom prst="rect">
+            <a:avLst/>
+          </a:prstGeom>
+        </p:spPr>
+        <p:txBody>
+          <a:bodyPr vert="horz" lIns="91440" tIns="45720" rIns="91440" bIns="45720" rtlCol="0" anchor="t" wrap="square">
             <a:normAutofit/>
           </a:bodyPr>
           <a:lstStyle/>
@@ -4208,15 +2651,15 @@
         </p:nvSpPr>
         <p:spPr>
           <a:xfrm>
-            <a:off x="457200" y="1600200"/>
-            <a:ext cx="8229600" cy="4525963"/>
-          </a:xfrm>
-          <a:prstGeom prst="rect">
-            <a:avLst/>
-          </a:prstGeom>
-        </p:spPr>
-        <p:txBody>
-          <a:bodyPr vert="horz" lIns="91440" tIns="45720" rIns="91440" bIns="45720" rtlCol="0">
+            <a:off x="548640" y="1920240"/>
+            <a:ext cx="11091672" cy="4434840"/>
+          </a:xfrm>
+          <a:prstGeom prst="rect">
+            <a:avLst/>
+          </a:prstGeom>
+        </p:spPr>
+        <p:txBody>
+          <a:bodyPr vert="horz" lIns="91440" tIns="45720" rIns="91440" bIns="45720" rtlCol="0" wrap="square" anchor="t">
             <a:normAutofit/>
           </a:bodyPr>
           <a:lstStyle/>
@@ -4254,125 +2697,6 @@
               <a:rPr lang="en-US" smtClean="0"/>
               <a:t>Fifth level</a:t>
             </a:r>
-            <a:endParaRPr lang="en-US"/>
-          </a:p>
-        </p:txBody>
-      </p:sp>
-      <p:sp>
-        <p:nvSpPr>
-          <p:cNvPr id="4" name="Date Placeholder 3"/>
-          <p:cNvSpPr>
-            <a:spLocks noGrp="1"/>
-          </p:cNvSpPr>
-          <p:nvPr>
-            <p:ph type="dt" sz="half" idx="2"/>
-          </p:nvPr>
-        </p:nvSpPr>
-        <p:spPr>
-          <a:xfrm>
-            <a:off x="457200" y="6356350"/>
-            <a:ext cx="2133600" cy="365125"/>
-          </a:xfrm>
-          <a:prstGeom prst="rect">
-            <a:avLst/>
-          </a:prstGeom>
-        </p:spPr>
-        <p:txBody>
-          <a:bodyPr vert="horz" lIns="91440" tIns="45720" rIns="91440" bIns="45720" rtlCol="0" anchor="ctr"/>
-          <a:lstStyle>
-            <a:lvl1pPr algn="l">
-              <a:defRPr sz="1200">
-                <a:solidFill>
-                  <a:schemeClr val="tx1">
-                    <a:tint val="75000"/>
-                  </a:schemeClr>
-                </a:solidFill>
-              </a:defRPr>
-            </a:lvl1pPr>
-          </a:lstStyle>
-          <a:p>
-            <a:fld id="{5BCAD085-E8A6-8845-BD4E-CB4CCA059FC4}" type="datetimeFigureOut">
-              <a:rPr lang="en-US" smtClean="0"/>
-              <a:t>1/27/13</a:t>
-            </a:fld>
-            <a:endParaRPr lang="en-US"/>
-          </a:p>
-        </p:txBody>
-      </p:sp>
-      <p:sp>
-        <p:nvSpPr>
-          <p:cNvPr id="5" name="Footer Placeholder 4"/>
-          <p:cNvSpPr>
-            <a:spLocks noGrp="1"/>
-          </p:cNvSpPr>
-          <p:nvPr>
-            <p:ph type="ftr" sz="quarter" idx="3"/>
-          </p:nvPr>
-        </p:nvSpPr>
-        <p:spPr>
-          <a:xfrm>
-            <a:off x="3124200" y="6356350"/>
-            <a:ext cx="2895600" cy="365125"/>
-          </a:xfrm>
-          <a:prstGeom prst="rect">
-            <a:avLst/>
-          </a:prstGeom>
-        </p:spPr>
-        <p:txBody>
-          <a:bodyPr vert="horz" lIns="91440" tIns="45720" rIns="91440" bIns="45720" rtlCol="0" anchor="ctr"/>
-          <a:lstStyle>
-            <a:lvl1pPr algn="ctr">
-              <a:defRPr sz="1200">
-                <a:solidFill>
-                  <a:schemeClr val="tx1">
-                    <a:tint val="75000"/>
-                  </a:schemeClr>
-                </a:solidFill>
-              </a:defRPr>
-            </a:lvl1pPr>
-          </a:lstStyle>
-          <a:p>
-            <a:endParaRPr lang="en-US"/>
-          </a:p>
-        </p:txBody>
-      </p:sp>
-      <p:sp>
-        <p:nvSpPr>
-          <p:cNvPr id="6" name="Slide Number Placeholder 5"/>
-          <p:cNvSpPr>
-            <a:spLocks noGrp="1"/>
-          </p:cNvSpPr>
-          <p:nvPr>
-            <p:ph type="sldNum" sz="quarter" idx="4"/>
-          </p:nvPr>
-        </p:nvSpPr>
-        <p:spPr>
-          <a:xfrm>
-            <a:off x="6553200" y="6356350"/>
-            <a:ext cx="2133600" cy="365125"/>
-          </a:xfrm>
-          <a:prstGeom prst="rect">
-            <a:avLst/>
-          </a:prstGeom>
-        </p:spPr>
-        <p:txBody>
-          <a:bodyPr vert="horz" lIns="91440" tIns="45720" rIns="91440" bIns="45720" rtlCol="0" anchor="ctr"/>
-          <a:lstStyle>
-            <a:lvl1pPr algn="r">
-              <a:defRPr sz="1200">
-                <a:solidFill>
-                  <a:schemeClr val="tx1">
-                    <a:tint val="75000"/>
-                  </a:schemeClr>
-                </a:solidFill>
-              </a:defRPr>
-            </a:lvl1pPr>
-          </a:lstStyle>
-          <a:p>
-            <a:fld id="{C1FF6DA9-008F-8B48-92A6-B652298478BF}" type="slidenum">
-              <a:rPr lang="en-US" smtClean="0"/>
-              <a:t>‹#›</a:t>
-            </a:fld>
             <a:endParaRPr lang="en-US"/>
           </a:p>
         </p:txBody>
@@ -4388,264 +2712,79 @@
   <p:sldLayoutIdLst>
     <p:sldLayoutId id="2147483649" r:id="rId1"/>
     <p:sldLayoutId id="2147483650" r:id="rId2"/>
-    <p:sldLayoutId id="2147483651" r:id="rId3"/>
-    <p:sldLayoutId id="2147483652" r:id="rId4"/>
-    <p:sldLayoutId id="2147483653" r:id="rId5"/>
-    <p:sldLayoutId id="2147483654" r:id="rId6"/>
-    <p:sldLayoutId id="2147483655" r:id="rId7"/>
-    <p:sldLayoutId id="2147483656" r:id="rId8"/>
-    <p:sldLayoutId id="2147483657" r:id="rId9"/>
-    <p:sldLayoutId id="2147483658" r:id="rId10"/>
-    <p:sldLayoutId id="2147483659" r:id="rId11"/>
+    <p:sldLayoutId id="2147483652" r:id="rId3"/>
+    <p:sldLayoutId id="2147483657" r:id="rId4"/>
+    <p:sldLayoutId id="2147483654" r:id="rId5"/>
+    <p:sldLayoutId id="2147483655" r:id="rId6"/>
   </p:sldLayoutIdLst>
   <p:txStyles>
     <p:titleStyle>
-      <a:lvl1pPr algn="ctr" defTabSz="457200" rtl="0" eaLnBrk="1" latinLnBrk="0" hangingPunct="1">
-        <a:spcBef>
-          <a:spcPct val="0"/>
-        </a:spcBef>
+      <a:lvl1pPr marL="0" indent="0">
         <a:buNone/>
-        <a:defRPr sz="4400" kern="1200">
+        <a:defRPr sz="3400" b="1">
           <a:solidFill>
             <a:schemeClr val="tx1"/>
           </a:solidFill>
-          <a:latin typeface="+mj-lt"/>
-          <a:ea typeface="+mj-ea"/>
-          <a:cs typeface="+mj-cs"/>
+          <a:latin typeface="+mn-lt"/>
         </a:defRPr>
       </a:lvl1pPr>
     </p:titleStyle>
     <p:bodyStyle>
-      <a:lvl1pPr marL="342900" indent="-342900" algn="l" defTabSz="457200" rtl="0" eaLnBrk="1" latinLnBrk="0" hangingPunct="1">
-        <a:spcBef>
-          <a:spcPct val="20000"/>
-        </a:spcBef>
+      <a:lvl1pPr marL="274638" indent="-274638">
+        <a:spcAft>
+          <a:spcPts val="1800"/>
+        </a:spcAft>
+        <a:buClr>
+          <a:schemeClr val="accent1"/>
+        </a:buClr>
         <a:buFont typeface="Arial"/>
         <a:buChar char="•"/>
-        <a:defRPr sz="3200" kern="1200">
+        <a:defRPr sz="2600">
           <a:solidFill>
             <a:schemeClr val="tx1"/>
           </a:solidFill>
           <a:latin typeface="+mn-lt"/>
-          <a:ea typeface="+mn-ea"/>
-          <a:cs typeface="+mn-cs"/>
         </a:defRPr>
       </a:lvl1pPr>
-      <a:lvl2pPr marL="742950" indent="-285750" algn="l" defTabSz="457200" rtl="0" eaLnBrk="1" latinLnBrk="0" hangingPunct="1">
-        <a:spcBef>
-          <a:spcPct val="20000"/>
-        </a:spcBef>
+      <a:lvl2pPr marL="549275" indent="-274638">
+        <a:spcAft>
+          <a:spcPts val="1400"/>
+        </a:spcAft>
+        <a:buNone/>
+        <a:defRPr sz="2100">
+          <a:solidFill>
+            <a:schemeClr val="accent4"/>
+          </a:solidFill>
+          <a:latin typeface="+mn-lt"/>
+        </a:defRPr>
+      </a:lvl2pPr>
+      <a:lvl3pPr marL="823913" indent="-274638">
+        <a:spcAft>
+          <a:spcPts val="1200"/>
+        </a:spcAft>
+        <a:buClr>
+          <a:schemeClr val="accent4"/>
+        </a:buClr>
         <a:buFont typeface="Arial"/>
         <a:buChar char="–"/>
-        <a:defRPr sz="2800" kern="1200">
+        <a:defRPr sz="1800">
+          <a:solidFill>
+            <a:schemeClr val="tx2"/>
+          </a:solidFill>
+          <a:latin typeface="+mn-lt"/>
+        </a:defRPr>
+      </a:lvl3pPr>
+    </p:bodyStyle>
+    <p:otherStyle>
+      <a:lvl1pPr marL="0" indent="0">
+        <a:buNone/>
+        <a:defRPr sz="1800">
           <a:solidFill>
             <a:schemeClr val="tx1"/>
           </a:solidFill>
           <a:latin typeface="+mn-lt"/>
-          <a:ea typeface="+mn-ea"/>
-          <a:cs typeface="+mn-cs"/>
-        </a:defRPr>
-      </a:lvl2pPr>
-      <a:lvl3pPr marL="1143000" indent="-228600" algn="l" defTabSz="457200" rtl="0" eaLnBrk="1" latinLnBrk="0" hangingPunct="1">
-        <a:spcBef>
-          <a:spcPct val="20000"/>
-        </a:spcBef>
-        <a:buFont typeface="Arial"/>
-        <a:buChar char="•"/>
-        <a:defRPr sz="2400" kern="1200">
-          <a:solidFill>
-            <a:schemeClr val="tx1"/>
-          </a:solidFill>
-          <a:latin typeface="+mn-lt"/>
-          <a:ea typeface="+mn-ea"/>
-          <a:cs typeface="+mn-cs"/>
-        </a:defRPr>
-      </a:lvl3pPr>
-      <a:lvl4pPr marL="1600200" indent="-228600" algn="l" defTabSz="457200" rtl="0" eaLnBrk="1" latinLnBrk="0" hangingPunct="1">
-        <a:spcBef>
-          <a:spcPct val="20000"/>
-        </a:spcBef>
-        <a:buFont typeface="Arial"/>
-        <a:buChar char="–"/>
-        <a:defRPr sz="2000" kern="1200">
-          <a:solidFill>
-            <a:schemeClr val="tx1"/>
-          </a:solidFill>
-          <a:latin typeface="+mn-lt"/>
-          <a:ea typeface="+mn-ea"/>
-          <a:cs typeface="+mn-cs"/>
-        </a:defRPr>
-      </a:lvl4pPr>
-      <a:lvl5pPr marL="2057400" indent="-228600" algn="l" defTabSz="457200" rtl="0" eaLnBrk="1" latinLnBrk="0" hangingPunct="1">
-        <a:spcBef>
-          <a:spcPct val="20000"/>
-        </a:spcBef>
-        <a:buFont typeface="Arial"/>
-        <a:buChar char="»"/>
-        <a:defRPr sz="2000" kern="1200">
-          <a:solidFill>
-            <a:schemeClr val="tx1"/>
-          </a:solidFill>
-          <a:latin typeface="+mn-lt"/>
-          <a:ea typeface="+mn-ea"/>
-          <a:cs typeface="+mn-cs"/>
-        </a:defRPr>
-      </a:lvl5pPr>
-      <a:lvl6pPr marL="2514600" indent="-228600" algn="l" defTabSz="457200" rtl="0" eaLnBrk="1" latinLnBrk="0" hangingPunct="1">
-        <a:spcBef>
-          <a:spcPct val="20000"/>
-        </a:spcBef>
-        <a:buFont typeface="Arial"/>
-        <a:buChar char="•"/>
-        <a:defRPr sz="2000" kern="1200">
-          <a:solidFill>
-            <a:schemeClr val="tx1"/>
-          </a:solidFill>
-          <a:latin typeface="+mn-lt"/>
-          <a:ea typeface="+mn-ea"/>
-          <a:cs typeface="+mn-cs"/>
-        </a:defRPr>
-      </a:lvl6pPr>
-      <a:lvl7pPr marL="2971800" indent="-228600" algn="l" defTabSz="457200" rtl="0" eaLnBrk="1" latinLnBrk="0" hangingPunct="1">
-        <a:spcBef>
-          <a:spcPct val="20000"/>
-        </a:spcBef>
-        <a:buFont typeface="Arial"/>
-        <a:buChar char="•"/>
-        <a:defRPr sz="2000" kern="1200">
-          <a:solidFill>
-            <a:schemeClr val="tx1"/>
-          </a:solidFill>
-          <a:latin typeface="+mn-lt"/>
-          <a:ea typeface="+mn-ea"/>
-          <a:cs typeface="+mn-cs"/>
-        </a:defRPr>
-      </a:lvl7pPr>
-      <a:lvl8pPr marL="3429000" indent="-228600" algn="l" defTabSz="457200" rtl="0" eaLnBrk="1" latinLnBrk="0" hangingPunct="1">
-        <a:spcBef>
-          <a:spcPct val="20000"/>
-        </a:spcBef>
-        <a:buFont typeface="Arial"/>
-        <a:buChar char="•"/>
-        <a:defRPr sz="2000" kern="1200">
-          <a:solidFill>
-            <a:schemeClr val="tx1"/>
-          </a:solidFill>
-          <a:latin typeface="+mn-lt"/>
-          <a:ea typeface="+mn-ea"/>
-          <a:cs typeface="+mn-cs"/>
-        </a:defRPr>
-      </a:lvl8pPr>
-      <a:lvl9pPr marL="3886200" indent="-228600" algn="l" defTabSz="457200" rtl="0" eaLnBrk="1" latinLnBrk="0" hangingPunct="1">
-        <a:spcBef>
-          <a:spcPct val="20000"/>
-        </a:spcBef>
-        <a:buFont typeface="Arial"/>
-        <a:buChar char="•"/>
-        <a:defRPr sz="2000" kern="1200">
-          <a:solidFill>
-            <a:schemeClr val="tx1"/>
-          </a:solidFill>
-          <a:latin typeface="+mn-lt"/>
-          <a:ea typeface="+mn-ea"/>
-          <a:cs typeface="+mn-cs"/>
-        </a:defRPr>
-      </a:lvl9pPr>
-    </p:bodyStyle>
-    <p:otherStyle>
-      <a:defPPr>
-        <a:defRPr lang="en-US"/>
-      </a:defPPr>
-      <a:lvl1pPr marL="0" algn="l" defTabSz="457200" rtl="0" eaLnBrk="1" latinLnBrk="0" hangingPunct="1">
-        <a:defRPr sz="1800" kern="1200">
-          <a:solidFill>
-            <a:schemeClr val="tx1"/>
-          </a:solidFill>
-          <a:latin typeface="+mn-lt"/>
-          <a:ea typeface="+mn-ea"/>
-          <a:cs typeface="+mn-cs"/>
         </a:defRPr>
       </a:lvl1pPr>
-      <a:lvl2pPr marL="457200" algn="l" defTabSz="457200" rtl="0" eaLnBrk="1" latinLnBrk="0" hangingPunct="1">
-        <a:defRPr sz="1800" kern="1200">
-          <a:solidFill>
-            <a:schemeClr val="tx1"/>
-          </a:solidFill>
-          <a:latin typeface="+mn-lt"/>
-          <a:ea typeface="+mn-ea"/>
-          <a:cs typeface="+mn-cs"/>
-        </a:defRPr>
-      </a:lvl2pPr>
-      <a:lvl3pPr marL="914400" algn="l" defTabSz="457200" rtl="0" eaLnBrk="1" latinLnBrk="0" hangingPunct="1">
-        <a:defRPr sz="1800" kern="1200">
-          <a:solidFill>
-            <a:schemeClr val="tx1"/>
-          </a:solidFill>
-          <a:latin typeface="+mn-lt"/>
-          <a:ea typeface="+mn-ea"/>
-          <a:cs typeface="+mn-cs"/>
-        </a:defRPr>
-      </a:lvl3pPr>
-      <a:lvl4pPr marL="1371600" algn="l" defTabSz="457200" rtl="0" eaLnBrk="1" latinLnBrk="0" hangingPunct="1">
-        <a:defRPr sz="1800" kern="1200">
-          <a:solidFill>
-            <a:schemeClr val="tx1"/>
-          </a:solidFill>
-          <a:latin typeface="+mn-lt"/>
-          <a:ea typeface="+mn-ea"/>
-          <a:cs typeface="+mn-cs"/>
-        </a:defRPr>
-      </a:lvl4pPr>
-      <a:lvl5pPr marL="1828800" algn="l" defTabSz="457200" rtl="0" eaLnBrk="1" latinLnBrk="0" hangingPunct="1">
-        <a:defRPr sz="1800" kern="1200">
-          <a:solidFill>
-            <a:schemeClr val="tx1"/>
-          </a:solidFill>
-          <a:latin typeface="+mn-lt"/>
-          <a:ea typeface="+mn-ea"/>
-          <a:cs typeface="+mn-cs"/>
-        </a:defRPr>
-      </a:lvl5pPr>
-      <a:lvl6pPr marL="2286000" algn="l" defTabSz="457200" rtl="0" eaLnBrk="1" latinLnBrk="0" hangingPunct="1">
-        <a:defRPr sz="1800" kern="1200">
-          <a:solidFill>
-            <a:schemeClr val="tx1"/>
-          </a:solidFill>
-          <a:latin typeface="+mn-lt"/>
-          <a:ea typeface="+mn-ea"/>
-          <a:cs typeface="+mn-cs"/>
-        </a:defRPr>
-      </a:lvl6pPr>
-      <a:lvl7pPr marL="2743200" algn="l" defTabSz="457200" rtl="0" eaLnBrk="1" latinLnBrk="0" hangingPunct="1">
-        <a:defRPr sz="1800" kern="1200">
-          <a:solidFill>
-            <a:schemeClr val="tx1"/>
-          </a:solidFill>
-          <a:latin typeface="+mn-lt"/>
-          <a:ea typeface="+mn-ea"/>
-          <a:cs typeface="+mn-cs"/>
-        </a:defRPr>
-      </a:lvl7pPr>
-      <a:lvl8pPr marL="3200400" algn="l" defTabSz="457200" rtl="0" eaLnBrk="1" latinLnBrk="0" hangingPunct="1">
-        <a:defRPr sz="1800" kern="1200">
-          <a:solidFill>
-            <a:schemeClr val="tx1"/>
-          </a:solidFill>
-          <a:latin typeface="+mn-lt"/>
-          <a:ea typeface="+mn-ea"/>
-          <a:cs typeface="+mn-cs"/>
-        </a:defRPr>
-      </a:lvl8pPr>
-      <a:lvl9pPr marL="3657600" algn="l" defTabSz="457200" rtl="0" eaLnBrk="1" latinLnBrk="0" hangingPunct="1">
-        <a:defRPr sz="1800" kern="1200">
-          <a:solidFill>
-            <a:schemeClr val="tx1"/>
-          </a:solidFill>
-          <a:latin typeface="+mn-lt"/>
-          <a:ea typeface="+mn-ea"/>
-          <a:cs typeface="+mn-cs"/>
-        </a:defRPr>
-      </a:lvl9pPr>
     </p:otherStyle>
   </p:txStyles>
 </p:sldMaster>
@@ -8633,326 +6772,6 @@
     <a:masterClrMapping/>
   </p:clrMapOvr>
 </p:sld>
-</file>
-
-<file path=ppt/theme/theme1.xml><?xml version="1.0" encoding="utf-8"?>
-<a:theme xmlns:a="http://schemas.openxmlformats.org/drawingml/2006/main" name="Office Theme">
-  <a:themeElements>
-    <a:clrScheme name="Office">
-      <a:dk1>
-        <a:sysClr val="windowText" lastClr="000000"/>
-      </a:dk1>
-      <a:lt1>
-        <a:sysClr val="window" lastClr="FFFFFF"/>
-      </a:lt1>
-      <a:dk2>
-        <a:srgbClr val="1F497D"/>
-      </a:dk2>
-      <a:lt2>
-        <a:srgbClr val="EEECE1"/>
-      </a:lt2>
-      <a:accent1>
-        <a:srgbClr val="4F81BD"/>
-      </a:accent1>
-      <a:accent2>
-        <a:srgbClr val="C0504D"/>
-      </a:accent2>
-      <a:accent3>
-        <a:srgbClr val="9BBB59"/>
-      </a:accent3>
-      <a:accent4>
-        <a:srgbClr val="8064A2"/>
-      </a:accent4>
-      <a:accent5>
-        <a:srgbClr val="4BACC6"/>
-      </a:accent5>
-      <a:accent6>
-        <a:srgbClr val="F79646"/>
-      </a:accent6>
-      <a:hlink>
-        <a:srgbClr val="0000FF"/>
-      </a:hlink>
-      <a:folHlink>
-        <a:srgbClr val="800080"/>
-      </a:folHlink>
-    </a:clrScheme>
-    <a:fontScheme name="Office">
-      <a:majorFont>
-        <a:latin typeface="Calibri"/>
-        <a:ea typeface=""/>
-        <a:cs typeface=""/>
-        <a:font script="Jpan" typeface="ＭＳ Ｐゴシック"/>
-        <a:font script="Hang" typeface="맑은 고딕"/>
-        <a:font script="Hans" typeface="宋体"/>
-        <a:font script="Hant" typeface="新細明體"/>
-        <a:font script="Arab" typeface="Times New Roman"/>
-        <a:font script="Hebr" typeface="Times New Roman"/>
-        <a:font script="Thai" typeface="Angsana New"/>
-        <a:font script="Ethi" typeface="Nyala"/>
-        <a:font script="Beng" typeface="Vrinda"/>
-        <a:font script="Gujr" typeface="Shruti"/>
-        <a:font script="Khmr" typeface="MoolBoran"/>
-        <a:font script="Knda" typeface="Tunga"/>
-        <a:font script="Guru" typeface="Raavi"/>
-        <a:font script="Cans" typeface="Euphemia"/>
-        <a:font script="Cher" typeface="Plantagenet Cherokee"/>
-        <a:font script="Yiii" typeface="Microsoft Yi Baiti"/>
-        <a:font script="Tibt" typeface="Microsoft Himalaya"/>
-        <a:font script="Thaa" typeface="MV Boli"/>
-        <a:font script="Deva" typeface="Mangal"/>
-        <a:font script="Telu" typeface="Gautami"/>
-        <a:font script="Taml" typeface="Latha"/>
-        <a:font script="Syrc" typeface="Estrangelo Edessa"/>
-        <a:font script="Orya" typeface="Kalinga"/>
-        <a:font script="Mlym" typeface="Kartika"/>
-        <a:font script="Laoo" typeface="DokChampa"/>
-        <a:font script="Sinh" typeface="Iskoola Pota"/>
-        <a:font script="Mong" typeface="Mongolian Baiti"/>
-        <a:font script="Viet" typeface="Times New Roman"/>
-        <a:font script="Uigh" typeface="Microsoft Uighur"/>
-        <a:font script="Geor" typeface="Sylfaen"/>
-      </a:majorFont>
-      <a:minorFont>
-        <a:latin typeface="Calibri"/>
-        <a:ea typeface=""/>
-        <a:cs typeface=""/>
-        <a:font script="Jpan" typeface="ＭＳ Ｐゴシック"/>
-        <a:font script="Hang" typeface="맑은 고딕"/>
-        <a:font script="Hans" typeface="宋体"/>
-        <a:font script="Hant" typeface="新細明體"/>
-        <a:font script="Arab" typeface="Arial"/>
-        <a:font script="Hebr" typeface="Arial"/>
-        <a:font script="Thai" typeface="Cordia New"/>
-        <a:font script="Ethi" typeface="Nyala"/>
-        <a:font script="Beng" typeface="Vrinda"/>
-        <a:font script="Gujr" typeface="Shruti"/>
-        <a:font script="Khmr" typeface="DaunPenh"/>
-        <a:font script="Knda" typeface="Tunga"/>
-        <a:font script="Guru" typeface="Raavi"/>
-        <a:font script="Cans" typeface="Euphemia"/>
-        <a:font script="Cher" typeface="Plantagenet Cherokee"/>
-        <a:font script="Yiii" typeface="Microsoft Yi Baiti"/>
-        <a:font script="Tibt" typeface="Microsoft Himalaya"/>
-        <a:font script="Thaa" typeface="MV Boli"/>
-        <a:font script="Deva" typeface="Mangal"/>
-        <a:font script="Telu" typeface="Gautami"/>
-        <a:font script="Taml" typeface="Latha"/>
-        <a:font script="Syrc" typeface="Estrangelo Edessa"/>
-        <a:font script="Orya" typeface="Kalinga"/>
-        <a:font script="Mlym" typeface="Kartika"/>
-        <a:font script="Laoo" typeface="DokChampa"/>
-        <a:font script="Sinh" typeface="Iskoola Pota"/>
-        <a:font script="Mong" typeface="Mongolian Baiti"/>
-        <a:font script="Viet" typeface="Arial"/>
-        <a:font script="Uigh" typeface="Microsoft Uighur"/>
-        <a:font script="Geor" typeface="Sylfaen"/>
-      </a:minorFont>
-    </a:fontScheme>
-    <a:fmtScheme name="Office">
-      <a:fillStyleLst>
-        <a:solidFill>
-          <a:schemeClr val="phClr"/>
-        </a:solidFill>
-        <a:gradFill rotWithShape="1">
-          <a:gsLst>
-            <a:gs pos="0">
-              <a:schemeClr val="phClr">
-                <a:tint val="50000"/>
-                <a:satMod val="300000"/>
-              </a:schemeClr>
-            </a:gs>
-            <a:gs pos="35000">
-              <a:schemeClr val="phClr">
-                <a:tint val="37000"/>
-                <a:satMod val="300000"/>
-              </a:schemeClr>
-            </a:gs>
-            <a:gs pos="100000">
-              <a:schemeClr val="phClr">
-                <a:tint val="15000"/>
-                <a:satMod val="350000"/>
-              </a:schemeClr>
-            </a:gs>
-          </a:gsLst>
-          <a:lin ang="16200000" scaled="1"/>
-        </a:gradFill>
-        <a:gradFill rotWithShape="1">
-          <a:gsLst>
-            <a:gs pos="0">
-              <a:schemeClr val="phClr">
-                <a:tint val="100000"/>
-                <a:shade val="100000"/>
-                <a:satMod val="130000"/>
-              </a:schemeClr>
-            </a:gs>
-            <a:gs pos="100000">
-              <a:schemeClr val="phClr">
-                <a:tint val="50000"/>
-                <a:shade val="100000"/>
-                <a:satMod val="350000"/>
-              </a:schemeClr>
-            </a:gs>
-          </a:gsLst>
-          <a:lin ang="16200000" scaled="0"/>
-        </a:gradFill>
-      </a:fillStyleLst>
-      <a:lnStyleLst>
-        <a:ln w="9525" cap="flat" cmpd="sng" algn="ctr">
-          <a:solidFill>
-            <a:schemeClr val="phClr">
-              <a:shade val="95000"/>
-              <a:satMod val="105000"/>
-            </a:schemeClr>
-          </a:solidFill>
-          <a:prstDash val="solid"/>
-        </a:ln>
-        <a:ln w="25400" cap="flat" cmpd="sng" algn="ctr">
-          <a:solidFill>
-            <a:schemeClr val="phClr"/>
-          </a:solidFill>
-          <a:prstDash val="solid"/>
-        </a:ln>
-        <a:ln w="38100" cap="flat" cmpd="sng" algn="ctr">
-          <a:solidFill>
-            <a:schemeClr val="phClr"/>
-          </a:solidFill>
-          <a:prstDash val="solid"/>
-        </a:ln>
-      </a:lnStyleLst>
-      <a:effectStyleLst>
-        <a:effectStyle>
-          <a:effectLst>
-            <a:outerShdw blurRad="40000" dist="20000" dir="5400000" rotWithShape="0">
-              <a:srgbClr val="000000">
-                <a:alpha val="38000"/>
-              </a:srgbClr>
-            </a:outerShdw>
-          </a:effectLst>
-        </a:effectStyle>
-        <a:effectStyle>
-          <a:effectLst>
-            <a:outerShdw blurRad="40000" dist="23000" dir="5400000" rotWithShape="0">
-              <a:srgbClr val="000000">
-                <a:alpha val="35000"/>
-              </a:srgbClr>
-            </a:outerShdw>
-          </a:effectLst>
-        </a:effectStyle>
-        <a:effectStyle>
-          <a:effectLst>
-            <a:outerShdw blurRad="40000" dist="23000" dir="5400000" rotWithShape="0">
-              <a:srgbClr val="000000">
-                <a:alpha val="35000"/>
-              </a:srgbClr>
-            </a:outerShdw>
-          </a:effectLst>
-          <a:scene3d>
-            <a:camera prst="orthographicFront">
-              <a:rot lat="0" lon="0" rev="0"/>
-            </a:camera>
-            <a:lightRig rig="threePt" dir="t">
-              <a:rot lat="0" lon="0" rev="1200000"/>
-            </a:lightRig>
-          </a:scene3d>
-          <a:sp3d>
-            <a:bevelT w="63500" h="25400"/>
-          </a:sp3d>
-        </a:effectStyle>
-      </a:effectStyleLst>
-      <a:bgFillStyleLst>
-        <a:solidFill>
-          <a:schemeClr val="phClr"/>
-        </a:solidFill>
-        <a:gradFill rotWithShape="1">
-          <a:gsLst>
-            <a:gs pos="0">
-              <a:schemeClr val="phClr">
-                <a:tint val="40000"/>
-                <a:satMod val="350000"/>
-              </a:schemeClr>
-            </a:gs>
-            <a:gs pos="40000">
-              <a:schemeClr val="phClr">
-                <a:tint val="45000"/>
-                <a:shade val="99000"/>
-                <a:satMod val="350000"/>
-              </a:schemeClr>
-            </a:gs>
-            <a:gs pos="100000">
-              <a:schemeClr val="phClr">
-                <a:shade val="20000"/>
-                <a:satMod val="255000"/>
-              </a:schemeClr>
-            </a:gs>
-          </a:gsLst>
-          <a:path path="circle">
-            <a:fillToRect l="50000" t="-80000" r="50000" b="180000"/>
-          </a:path>
-        </a:gradFill>
-        <a:gradFill rotWithShape="1">
-          <a:gsLst>
-            <a:gs pos="0">
-              <a:schemeClr val="phClr">
-                <a:tint val="80000"/>
-                <a:satMod val="300000"/>
-              </a:schemeClr>
-            </a:gs>
-            <a:gs pos="100000">
-              <a:schemeClr val="phClr">
-                <a:shade val="30000"/>
-                <a:satMod val="200000"/>
-              </a:schemeClr>
-            </a:gs>
-          </a:gsLst>
-          <a:path path="circle">
-            <a:fillToRect l="50000" t="50000" r="50000" b="50000"/>
-          </a:path>
-        </a:gradFill>
-      </a:bgFillStyleLst>
-    </a:fmtScheme>
-  </a:themeElements>
-  <a:objectDefaults>
-    <a:spDef>
-      <a:spPr/>
-      <a:bodyPr/>
-      <a:lstStyle/>
-      <a:style>
-        <a:lnRef idx="1">
-          <a:schemeClr val="accent1"/>
-        </a:lnRef>
-        <a:fillRef idx="3">
-          <a:schemeClr val="accent1"/>
-        </a:fillRef>
-        <a:effectRef idx="2">
-          <a:schemeClr val="accent1"/>
-        </a:effectRef>
-        <a:fontRef idx="minor">
-          <a:schemeClr val="lt1"/>
-        </a:fontRef>
-      </a:style>
-    </a:spDef>
-    <a:lnDef>
-      <a:spPr/>
-      <a:bodyPr/>
-      <a:lstStyle/>
-      <a:style>
-        <a:lnRef idx="2">
-          <a:schemeClr val="accent1"/>
-        </a:lnRef>
-        <a:fillRef idx="0">
-          <a:schemeClr val="accent1"/>
-        </a:fillRef>
-        <a:effectRef idx="1">
-          <a:schemeClr val="accent1"/>
-        </a:effectRef>
-        <a:fontRef idx="minor">
-          <a:schemeClr val="tx1"/>
-        </a:fontRef>
-      </a:style>
-    </a:lnDef>
-  </a:objectDefaults>
-  <a:extraClrSchemeLst/>
-</a:theme>
 </file>
 
 <file path=ppt/theme/theme2.xml><?xml version="1.0" encoding="utf-8"?>
@@ -9273,4 +7092,324 @@
   </a:objectDefaults>
   <a:extraClrSchemeLst/>
 </a:theme>
+</file>
+
+<file path=ppt/theme/theme4.xml><?xml version="1.0" encoding="utf-8"?>
+<a:theme xmlns:a="http://schemas.openxmlformats.org/drawingml/2006/main" name="MSACL DS301">
+  <a:themeElements>
+    <a:clrScheme name="MSACL DS301">
+      <a:dk1>
+        <a:srgbClr val="1B2025"/>
+      </a:dk1>
+      <a:lt1>
+        <a:srgbClr val="FBFBF8"/>
+      </a:lt1>
+      <a:dk2>
+        <a:srgbClr val="3D444C"/>
+      </a:dk2>
+      <a:lt2>
+        <a:srgbClr val="E3F0EF"/>
+      </a:lt2>
+      <a:accent1>
+        <a:srgbClr val="0E7C7B"/>
+      </a:accent1>
+      <a:accent2>
+        <a:srgbClr val="E09E2F"/>
+      </a:accent2>
+      <a:accent3>
+        <a:srgbClr val="C4534F"/>
+      </a:accent3>
+      <a:accent4>
+        <a:srgbClr val="8A9099"/>
+      </a:accent4>
+      <a:accent5>
+        <a:srgbClr val="A9721A"/>
+      </a:accent5>
+      <a:accent6>
+        <a:srgbClr val="D9D9D2"/>
+      </a:accent6>
+      <a:hlink>
+        <a:srgbClr val="0E7C7B"/>
+      </a:hlink>
+      <a:folHlink>
+        <a:srgbClr val="A9721A"/>
+      </a:folHlink>
+    </a:clrScheme>
+    <a:fontScheme name="MSACL DS301">
+      <a:majorFont>
+        <a:latin typeface="Avenir Next"/>
+        <a:ea typeface=""/>
+        <a:cs typeface=""/>
+        <a:font script="Jpan" typeface="ＭＳ Ｐゴシック"/>
+        <a:font script="Hang" typeface="맑은 고딕"/>
+        <a:font script="Hans" typeface="宋体"/>
+        <a:font script="Hant" typeface="新細明體"/>
+        <a:font script="Arab" typeface="Times New Roman"/>
+        <a:font script="Hebr" typeface="Times New Roman"/>
+        <a:font script="Thai" typeface="Angsana New"/>
+        <a:font script="Ethi" typeface="Nyala"/>
+        <a:font script="Beng" typeface="Vrinda"/>
+        <a:font script="Gujr" typeface="Shruti"/>
+        <a:font script="Khmr" typeface="MoolBoran"/>
+        <a:font script="Knda" typeface="Tunga"/>
+        <a:font script="Guru" typeface="Raavi"/>
+        <a:font script="Cans" typeface="Euphemia"/>
+        <a:font script="Cher" typeface="Plantagenet Cherokee"/>
+        <a:font script="Yiii" typeface="Microsoft Yi Baiti"/>
+        <a:font script="Tibt" typeface="Microsoft Himalaya"/>
+        <a:font script="Thaa" typeface="MV Boli"/>
+        <a:font script="Deva" typeface="Mangal"/>
+        <a:font script="Telu" typeface="Gautami"/>
+        <a:font script="Taml" typeface="Latha"/>
+        <a:font script="Syrc" typeface="Estrangelo Edessa"/>
+        <a:font script="Orya" typeface="Kalinga"/>
+        <a:font script="Mlym" typeface="Kartika"/>
+        <a:font script="Laoo" typeface="DokChampa"/>
+        <a:font script="Sinh" typeface="Iskoola Pota"/>
+        <a:font script="Mong" typeface="Mongolian Baiti"/>
+        <a:font script="Viet" typeface="Times New Roman"/>
+        <a:font script="Uigh" typeface="Microsoft Uighur"/>
+        <a:font script="Geor" typeface="Sylfaen"/>
+      </a:majorFont>
+      <a:minorFont>
+        <a:latin typeface="Avenir Next"/>
+        <a:ea typeface=""/>
+        <a:cs typeface=""/>
+        <a:font script="Jpan" typeface="ＭＳ Ｐゴシック"/>
+        <a:font script="Hang" typeface="맑은 고딕"/>
+        <a:font script="Hans" typeface="宋体"/>
+        <a:font script="Hant" typeface="新細明體"/>
+        <a:font script="Arab" typeface="Arial"/>
+        <a:font script="Hebr" typeface="Arial"/>
+        <a:font script="Thai" typeface="Cordia New"/>
+        <a:font script="Ethi" typeface="Nyala"/>
+        <a:font script="Beng" typeface="Vrinda"/>
+        <a:font script="Gujr" typeface="Shruti"/>
+        <a:font script="Khmr" typeface="DaunPenh"/>
+        <a:font script="Knda" typeface="Tunga"/>
+        <a:font script="Guru" typeface="Raavi"/>
+        <a:font script="Cans" typeface="Euphemia"/>
+        <a:font script="Cher" typeface="Plantagenet Cherokee"/>
+        <a:font script="Yiii" typeface="Microsoft Yi Baiti"/>
+        <a:font script="Tibt" typeface="Microsoft Himalaya"/>
+        <a:font script="Thaa" typeface="MV Boli"/>
+        <a:font script="Deva" typeface="Mangal"/>
+        <a:font script="Telu" typeface="Gautami"/>
+        <a:font script="Taml" typeface="Latha"/>
+        <a:font script="Syrc" typeface="Estrangelo Edessa"/>
+        <a:font script="Orya" typeface="Kalinga"/>
+        <a:font script="Mlym" typeface="Kartika"/>
+        <a:font script="Laoo" typeface="DokChampa"/>
+        <a:font script="Sinh" typeface="Iskoola Pota"/>
+        <a:font script="Mong" typeface="Mongolian Baiti"/>
+        <a:font script="Viet" typeface="Arial"/>
+        <a:font script="Uigh" typeface="Microsoft Uighur"/>
+        <a:font script="Geor" typeface="Sylfaen"/>
+      </a:minorFont>
+    </a:fontScheme>
+    <a:fmtScheme name="Office">
+      <a:fillStyleLst>
+        <a:solidFill>
+          <a:schemeClr val="phClr"/>
+        </a:solidFill>
+        <a:gradFill rotWithShape="1">
+          <a:gsLst>
+            <a:gs pos="0">
+              <a:schemeClr val="phClr">
+                <a:tint val="50000"/>
+                <a:satMod val="300000"/>
+              </a:schemeClr>
+            </a:gs>
+            <a:gs pos="35000">
+              <a:schemeClr val="phClr">
+                <a:tint val="37000"/>
+                <a:satMod val="300000"/>
+              </a:schemeClr>
+            </a:gs>
+            <a:gs pos="100000">
+              <a:schemeClr val="phClr">
+                <a:tint val="15000"/>
+                <a:satMod val="350000"/>
+              </a:schemeClr>
+            </a:gs>
+          </a:gsLst>
+          <a:lin ang="16200000" scaled="1"/>
+        </a:gradFill>
+        <a:gradFill rotWithShape="1">
+          <a:gsLst>
+            <a:gs pos="0">
+              <a:schemeClr val="phClr">
+                <a:tint val="100000"/>
+                <a:shade val="100000"/>
+                <a:satMod val="130000"/>
+              </a:schemeClr>
+            </a:gs>
+            <a:gs pos="100000">
+              <a:schemeClr val="phClr">
+                <a:tint val="50000"/>
+                <a:shade val="100000"/>
+                <a:satMod val="350000"/>
+              </a:schemeClr>
+            </a:gs>
+          </a:gsLst>
+          <a:lin ang="16200000" scaled="0"/>
+        </a:gradFill>
+      </a:fillStyleLst>
+      <a:lnStyleLst>
+        <a:ln w="9525" cap="flat" cmpd="sng" algn="ctr">
+          <a:solidFill>
+            <a:schemeClr val="phClr">
+              <a:shade val="95000"/>
+              <a:satMod val="105000"/>
+            </a:schemeClr>
+          </a:solidFill>
+          <a:prstDash val="solid"/>
+        </a:ln>
+        <a:ln w="25400" cap="flat" cmpd="sng" algn="ctr">
+          <a:solidFill>
+            <a:schemeClr val="phClr"/>
+          </a:solidFill>
+          <a:prstDash val="solid"/>
+        </a:ln>
+        <a:ln w="38100" cap="flat" cmpd="sng" algn="ctr">
+          <a:solidFill>
+            <a:schemeClr val="phClr"/>
+          </a:solidFill>
+          <a:prstDash val="solid"/>
+        </a:ln>
+      </a:lnStyleLst>
+      <a:effectStyleLst>
+        <a:effectStyle>
+          <a:effectLst>
+            <a:outerShdw blurRad="40000" dist="20000" dir="5400000" rotWithShape="0">
+              <a:srgbClr val="000000">
+                <a:alpha val="38000"/>
+              </a:srgbClr>
+            </a:outerShdw>
+          </a:effectLst>
+        </a:effectStyle>
+        <a:effectStyle>
+          <a:effectLst>
+            <a:outerShdw blurRad="40000" dist="23000" dir="5400000" rotWithShape="0">
+              <a:srgbClr val="000000">
+                <a:alpha val="35000"/>
+              </a:srgbClr>
+            </a:outerShdw>
+          </a:effectLst>
+        </a:effectStyle>
+        <a:effectStyle>
+          <a:effectLst>
+            <a:outerShdw blurRad="40000" dist="23000" dir="5400000" rotWithShape="0">
+              <a:srgbClr val="000000">
+                <a:alpha val="35000"/>
+              </a:srgbClr>
+            </a:outerShdw>
+          </a:effectLst>
+          <a:scene3d>
+            <a:camera prst="orthographicFront">
+              <a:rot lat="0" lon="0" rev="0"/>
+            </a:camera>
+            <a:lightRig rig="threePt" dir="t">
+              <a:rot lat="0" lon="0" rev="1200000"/>
+            </a:lightRig>
+          </a:scene3d>
+          <a:sp3d>
+            <a:bevelT w="63500" h="25400"/>
+          </a:sp3d>
+        </a:effectStyle>
+      </a:effectStyleLst>
+      <a:bgFillStyleLst>
+        <a:solidFill>
+          <a:schemeClr val="phClr"/>
+        </a:solidFill>
+        <a:gradFill rotWithShape="1">
+          <a:gsLst>
+            <a:gs pos="0">
+              <a:schemeClr val="phClr">
+                <a:tint val="40000"/>
+                <a:satMod val="350000"/>
+              </a:schemeClr>
+            </a:gs>
+            <a:gs pos="40000">
+              <a:schemeClr val="phClr">
+                <a:tint val="45000"/>
+                <a:shade val="99000"/>
+                <a:satMod val="350000"/>
+              </a:schemeClr>
+            </a:gs>
+            <a:gs pos="100000">
+              <a:schemeClr val="phClr">
+                <a:shade val="20000"/>
+                <a:satMod val="255000"/>
+              </a:schemeClr>
+            </a:gs>
+          </a:gsLst>
+          <a:path path="circle">
+            <a:fillToRect l="50000" t="-80000" r="50000" b="180000"/>
+          </a:path>
+        </a:gradFill>
+        <a:gradFill rotWithShape="1">
+          <a:gsLst>
+            <a:gs pos="0">
+              <a:schemeClr val="phClr">
+                <a:tint val="80000"/>
+                <a:satMod val="300000"/>
+              </a:schemeClr>
+            </a:gs>
+            <a:gs pos="100000">
+              <a:schemeClr val="phClr">
+                <a:shade val="30000"/>
+                <a:satMod val="200000"/>
+              </a:schemeClr>
+            </a:gs>
+          </a:gsLst>
+          <a:path path="circle">
+            <a:fillToRect l="50000" t="50000" r="50000" b="50000"/>
+          </a:path>
+        </a:gradFill>
+      </a:bgFillStyleLst>
+    </a:fmtScheme>
+  </a:themeElements>
+  <a:objectDefaults>
+    <a:spDef>
+      <a:spPr/>
+      <a:bodyPr/>
+      <a:lstStyle/>
+      <a:style>
+        <a:lnRef idx="1">
+          <a:schemeClr val="accent1"/>
+        </a:lnRef>
+        <a:fillRef idx="3">
+          <a:schemeClr val="accent1"/>
+        </a:fillRef>
+        <a:effectRef idx="2">
+          <a:schemeClr val="accent1"/>
+        </a:effectRef>
+        <a:fontRef idx="minor">
+          <a:schemeClr val="lt1"/>
+        </a:fontRef>
+      </a:style>
+    </a:spDef>
+    <a:lnDef>
+      <a:spPr/>
+      <a:bodyPr/>
+      <a:lstStyle/>
+      <a:style>
+        <a:lnRef idx="2">
+          <a:schemeClr val="accent1"/>
+        </a:lnRef>
+        <a:fillRef idx="0">
+          <a:schemeClr val="accent1"/>
+        </a:fillRef>
+        <a:effectRef idx="1">
+          <a:schemeClr val="accent1"/>
+        </a:effectRef>
+        <a:fontRef idx="minor">
+          <a:schemeClr val="tx1"/>
+        </a:fontRef>
+      </a:style>
+    </a:lnDef>
+  </a:objectDefaults>
+  <a:extraClrSchemeLst/>
+</a:theme>
 </file>
</xml_diff>

<commit_message>
slides: Lecture 14 — chain-of-thought slide before ReAct
New CHATBOT -> AGENT 2 OF 4 slide between the agent definition and the annotated ReAct
transcript (21 -> 22 slides; section renumbered). Notes on the neighbouring slides link
to it; Learning_outcomes and DECISIONS updated.

Co-Authored-By: Claude Opus 5.5 <noreply@anthropic.com>
</commit_message>
<xml_diff>
--- a/slides/pptx/lecture14_agents.pptx
+++ b/slides/pptx/lecture14_agents.pptx
@@ -8,6 +8,7 @@
     <p:sldId id="256" r:id="rId7"/>
     <p:sldId id="257" r:id="rId9"/>
     <p:sldId id="258" r:id="rId10"/>
+    <p:sldId id="277" r:id="rId29"/>
     <p:sldId id="259" r:id="rId11"/>
     <p:sldId id="260" r:id="rId12"/>
     <p:sldId id="261" r:id="rId13"/>
@@ -1465,6 +1466,76 @@
 </p:notes>
 </file>
 
+<file path=ppt/notesSlides/notesSlide22.xml><?xml version="1.0" encoding="utf-8"?>
+<p:notes xmlns:a="http://schemas.openxmlformats.org/drawingml/2006/main" xmlns:p="http://schemas.openxmlformats.org/presentationml/2006/main" xmlns:r="http://schemas.openxmlformats.org/officeDocument/2006/relationships">
+  <p:cSld>
+    <p:spTree>
+      <p:nvGrpSpPr>
+        <p:cNvPr id="1" name=""/>
+        <p:cNvGrpSpPr/>
+        <p:nvPr/>
+      </p:nvGrpSpPr>
+      <p:grpSpPr>
+        <a:xfrm>
+          <a:off x="0" y="0"/>
+          <a:ext cx="0" cy="0"/>
+          <a:chOff x="0" y="0"/>
+          <a:chExt cx="0" cy="0"/>
+        </a:xfrm>
+      </p:grpSpPr>
+      <p:sp>
+        <p:nvSpPr>
+          <p:cNvPr id="2" name="Slide Image Placeholder 1"/>
+          <p:cNvSpPr>
+            <a:spLocks noGrp="1"/>
+          </p:cNvSpPr>
+          <p:nvPr>
+            <p:ph type="sldImg" idx="2"/>
+          </p:nvPr>
+        </p:nvSpPr>
+        <p:spPr/>
+      </p:sp>
+      <p:sp>
+        <p:nvSpPr>
+          <p:cNvPr id="3" name="Notes Placeholder 2"/>
+          <p:cNvSpPr>
+            <a:spLocks noGrp="1"/>
+          </p:cNvSpPr>
+          <p:nvPr>
+            <p:ph type="body" idx="3" sz="quarter"/>
+          </p:nvPr>
+        </p:nvSpPr>
+        <p:spPr/>
+        <p:txBody>
+          <a:bodyPr/>
+          <a:lstStyle/>
+          <a:p>
+            <a:r>
+              <a:t>ADDED 2026-10-06 (instructor): chain of thought, the idea ReAct is built on — about 3 minutes, no quiz item. CHAIN OF THOUGHT (Wei et al., NeurIPS 2022) means prompting the model to write out its intermediate reasoning before it gives the answer — 'show your working', 'think step by step'. WALK THE EXAMPLE: theoretical m/z 524.2652, observed 524.2681, limit ±2 ppm. Asked to answer straight away, a model can be swayed by how small the gap looks (0.003 m/z) and wave it through. Asked to show its working: step 1, difference = 524.2681 − 524.2652 = 0.0029; step 2, ppm = 0.0029 ÷ 524.2652 × 10⁶ = 5.5 ppm (exactly 5.53); step 3, 5.5 &gt; 2, so it is OUT of spec. Why it helps: the model produces its answer one token at a time (Lecture 13), so writing the steps out gives it room to compute intermediate results instead of jumping to a conclusion — the same reason we ask students to show their working. Honest framing: today's strong models often get this one right even when answering directly, and reasoning models do this internally; the left panel shows the failure the technique was invented to fix. THE BRIDGE, bottom line of the figure: every step here used only numbers that were in the prompt. Ask 'does QC-04 pass?' when QC-04 lives in a file, and a chain of thought can only reason its way to an invented number — stage 2 of the live demo shows exactly that. ReAct, next slide, keeps these Thoughts and interleaves them with ACTIONS that fetch the real data: ReAct = chain-of-thought reasoning + tool calls.</a:t>
+            </a:r>
+          </a:p>
+        </p:txBody>
+      </p:sp>
+      <p:sp>
+        <p:nvSpPr>
+          <p:cNvPr id="4" name="Slide Number Placeholder 3"/>
+          <p:cNvSpPr>
+            <a:spLocks noGrp="1"/>
+          </p:cNvSpPr>
+          <p:nvPr>
+            <p:ph type="sldNum" idx="5" sz="quarter"/>
+          </p:nvPr>
+        </p:nvSpPr>
+        <p:spPr/>
+      </p:sp>
+    </p:spTree>
+  </p:cSld>
+  <p:clrMapOvr>
+    <a:masterClrMapping/>
+  </p:clrMapOvr>
+</p:notes>
+</file>
+
 <file path=ppt/notesSlides/notesSlide3.xml><?xml version="1.0" encoding="utf-8"?>
 <p:notes xmlns:a="http://schemas.openxmlformats.org/drawingml/2006/main" xmlns:p="http://schemas.openxmlformats.org/presentationml/2006/main" xmlns:r="http://schemas.openxmlformats.org/officeDocument/2006/relationships">
   <p:cSld>
@@ -1510,7 +1581,7 @@
           <a:lstStyle/>
           <a:p>
             <a:r>
-              <a:t>Demystify 'agent' in one picture. On the left, a plain chatbot: prompt in, reply out, answering only from what the model already learned — it cannot touch your files or run anything. On the right, an AGENT: the SAME LLM, now given a set of TOOLS (read a file, run code, make a plot, search) and run in a LOOP — it reasons about the next step, acts by calling a tool, observes what came back, and goes around again, keeping a memory of the run. That is the whole idea; there is no new neural architecture here — an agent is a wiring pattern around an LLM. One-line callback to Lecture 13 (say it out loud): reinforcement-style feedback and reward is how these reason→act behaviours get TRAINED — the model was tuned (RLHF and related) to plan, call tools, and use their results well. Next slide we watch the loop turn, step by step, on a real-looking MS-analysis transcript.</a:t>
+              <a:t>Demystify 'agent' in one picture. On the left, a plain chatbot: prompt in, reply out, answering only from what the model already learned — it cannot touch your files or run anything. On the right, an AGENT: the SAME LLM, now given a set of TOOLS (read a file, run code, make a plot, search) and run in a LOOP — it reasons about the next step, acts by calling a tool, observes what came back, and goes around again, keeping a memory of the run. That is the whole idea; there is no new neural architecture here — an agent is a wiring pattern around an LLM. One-line callback to Lecture 13 (say it out loud): reinforcement-style feedback and reward is how these reason→act behaviours get TRAINED — the model was tuned (RLHF and related) to plan, call tools, and use their results well. Next slide: chain of thought, the reasoning half of that loop; then we watch the loop turn, step by step, on a real-looking MS-analysis transcript.</a:t>
             </a:r>
           </a:p>
           <a:p/>
@@ -1581,7 +1652,7 @@
           <a:lstStyle/>
           <a:p>
             <a:r>
-              <a:t>The centrepiece (rule 6/9): the ReAct loop annotated on a real-looking transcript of the 'MS analysis assistant' asked to flag QC anomalies. Walk it top to bottom, naming each colour. THOUGHT (teal) = the agent REASONING: "I first need to open the QC table and see its columns" — a plan, no tool used yet. ACTION (amber) = the agent ACTING by calling a tool: read_csv("qc_runs.csv"). OBSERVATION (grey) = what the tool returned: 8 runs, columns run_id/mass_error_ppm/resolution/TIC. Then it loops again: THOUGHT — mass error must stay within ±2 ppm, check each run; ACTION — filter |mass_error_ppm| &gt; 2; OBSERVATION — R-07 = 5.3 ppm. Once more: THOUGHT — R-07 is far outside ±2 ppm, so it's the anomaly; ACTION — draft_summary(flag="R-07"); then the final ANSWER. The single distinction the room must carry to the quiz: a step is REASON if it's a Thought (planning/interpreting) and ACT if it's an Action (invoking a tool: read, run/compute, filter, plot, write/draft — so "compute the mean" is an act, because it runs a tool). Observations are the environment's replies, not the agent's steps. Note the qc_runs.csv here is a short standalone demo table, separate from the six-run QC-04 table on the follow-along handout — say so if anyone asks. One-line RL callback again: this reason-then-act behaviour is exactly what preference tuning (Lecture 13) shapes. Next slide the room labels a fresh transcript themselves (Quiz 14 Q1).</a:t>
+              <a:t>The centrepiece (rule 6/9). Open with the link to the previous slide: the THOUGHT lines are the chain of thought, and the ACTION lines are what plain chain of thought could not do. the ReAct loop annotated on a real-looking transcript of the 'MS analysis assistant' asked to flag QC anomalies. Walk it top to bottom, naming each colour. THOUGHT (teal) = the agent REASONING: "I first need to open the QC table and see its columns" — a plan, no tool used yet. ACTION (amber) = the agent ACTING by calling a tool: read_csv("qc_runs.csv"). OBSERVATION (grey) = what the tool returned: 8 runs, columns run_id/mass_error_ppm/resolution/TIC. Then it loops again: THOUGHT — mass error must stay within ±2 ppm, check each run; ACTION — filter |mass_error_ppm| &gt; 2; OBSERVATION — R-07 = 5.3 ppm. Once more: THOUGHT — R-07 is far outside ±2 ppm, so it's the anomaly; ACTION — draft_summary(flag="R-07"); then the final ANSWER. The single distinction the room must carry to the quiz: a step is REASON if it's a Thought (planning/interpreting) and ACT if it's an Action (invoking a tool: read, run/compute, filter, plot, write/draft — so "compute the mean" is an act, because it runs a tool). Observations are the environment's replies, not the agent's steps. Note the qc_runs.csv here is a short standalone demo table, separate from the six-run QC-04 table on the follow-along handout — say so if anyone asks. One-line RL callback again: this reason-then-act behaviour is exactly what preference tuning (Lecture 13) shapes. Next slide the room labels a fresh transcript themselves (Quiz 14 Q1).</a:t>
             </a:r>
           </a:p>
           <a:p/>
@@ -6428,6 +6499,224 @@
 </p:sld>
 </file>
 
+<file path=ppt/slides/slide22.xml><?xml version="1.0" encoding="utf-8"?>
+<p:sld xmlns:a="http://schemas.openxmlformats.org/drawingml/2006/main" xmlns:p="http://schemas.openxmlformats.org/presentationml/2006/main" xmlns:r="http://schemas.openxmlformats.org/officeDocument/2006/relationships">
+  <p:cSld>
+    <p:spTree>
+      <p:nvGrpSpPr>
+        <p:cNvPr id="1" name=""/>
+        <p:cNvGrpSpPr/>
+        <p:nvPr/>
+      </p:nvGrpSpPr>
+      <p:grpSpPr/>
+      <p:sp>
+        <p:nvSpPr>
+          <p:cNvPr id="2" name="Rectangle 1"/>
+          <p:cNvSpPr/>
+          <p:nvPr/>
+        </p:nvSpPr>
+        <p:spPr>
+          <a:xfrm>
+            <a:off x="0" y="0"/>
+            <a:ext cx="12191695" cy="6858000"/>
+          </a:xfrm>
+          <a:prstGeom prst="rect">
+            <a:avLst/>
+          </a:prstGeom>
+          <a:solidFill>
+            <a:srgbClr val="FBFBF8"/>
+          </a:solidFill>
+          <a:ln>
+            <a:noFill/>
+          </a:ln>
+          <a:effectLst/>
+        </p:spPr>
+        <p:style>
+          <a:lnRef idx="1">
+            <a:schemeClr val="accent1"/>
+          </a:lnRef>
+          <a:fillRef idx="3">
+            <a:schemeClr val="accent1"/>
+          </a:fillRef>
+          <a:effectRef idx="2">
+            <a:schemeClr val="accent1"/>
+          </a:effectRef>
+          <a:fontRef idx="minor">
+            <a:schemeClr val="lt1"/>
+          </a:fontRef>
+        </p:style>
+        <p:txBody>
+          <a:bodyPr rtlCol="0" anchor="ctr"/>
+          <a:lstStyle/>
+          <a:p>
+            <a:pPr algn="ctr"/>
+          </a:p>
+        </p:txBody>
+      </p:sp>
+      <p:sp>
+        <p:nvSpPr>
+          <p:cNvPr id="3" name="TextBox 2"/>
+          <p:cNvSpPr txBox="1"/>
+          <p:nvPr/>
+        </p:nvSpPr>
+        <p:spPr>
+          <a:xfrm>
+            <a:off x="548640" y="320040"/>
+            <a:ext cx="10972800" cy="365760"/>
+          </a:xfrm>
+          <a:prstGeom prst="rect">
+            <a:avLst/>
+          </a:prstGeom>
+          <a:noFill/>
+        </p:spPr>
+        <p:txBody>
+          <a:bodyPr wrap="square" anchor="t">
+            <a:spAutoFit/>
+          </a:bodyPr>
+          <a:lstStyle/>
+          <a:p>
+            <a:r>
+              <a:rPr sz="1300" b="1" i="0">
+                <a:solidFill>
+                  <a:srgbClr val="8A9099"/>
+                </a:solidFill>
+                <a:latin typeface="Menlo"/>
+              </a:rPr>
+              <a:t>CHATBOT → AGENT · 2 OF 4 · CHAIN OF THOUGHT · I-DO</a:t>
+            </a:r>
+          </a:p>
+        </p:txBody>
+      </p:sp>
+      <p:sp>
+        <p:nvSpPr>
+          <p:cNvPr id="4" name="TextBox 3"/>
+          <p:cNvSpPr txBox="1"/>
+          <p:nvPr/>
+        </p:nvSpPr>
+        <p:spPr>
+          <a:xfrm>
+            <a:off x="548640" y="731520"/>
+            <a:ext cx="11064240" cy="1005840"/>
+          </a:xfrm>
+          <a:prstGeom prst="rect">
+            <a:avLst/>
+          </a:prstGeom>
+          <a:noFill/>
+        </p:spPr>
+        <p:txBody>
+          <a:bodyPr wrap="square" anchor="t">
+            <a:spAutoFit/>
+          </a:bodyPr>
+          <a:lstStyle/>
+          <a:p>
+            <a:r>
+              <a:rPr sz="3400" b="1" i="0">
+                <a:solidFill>
+                  <a:srgbClr val="1B2025"/>
+                </a:solidFill>
+                <a:latin typeface="Avenir Next"/>
+              </a:rPr>
+              <a:t>Chain of thought: show the working first</a:t>
+            </a:r>
+          </a:p>
+        </p:txBody>
+      </p:sp>
+      <p:sp>
+        <p:nvSpPr>
+          <p:cNvPr id="6" name="Rectangle 5"/>
+          <p:cNvSpPr/>
+          <p:nvPr/>
+        </p:nvSpPr>
+        <p:spPr>
+          <a:xfrm>
+            <a:off x="548640" y="5538216"/>
+            <a:ext cx="10515600" cy="1182624"/>
+          </a:xfrm>
+          <a:prstGeom prst="rect">
+            <a:avLst/>
+          </a:prstGeom>
+          <a:solidFill>
+            <a:srgbClr val="E3F0EF"/>
+          </a:solidFill>
+          <a:ln w="12700">
+            <a:solidFill>
+              <a:srgbClr val="0E7C7B"/>
+            </a:solidFill>
+          </a:ln>
+          <a:effectLst/>
+        </p:spPr>
+        <p:style>
+          <a:lnRef idx="1">
+            <a:schemeClr val="accent1"/>
+          </a:lnRef>
+          <a:fillRef idx="3">
+            <a:schemeClr val="accent1"/>
+          </a:fillRef>
+          <a:effectRef idx="2">
+            <a:schemeClr val="accent1"/>
+          </a:effectRef>
+          <a:fontRef idx="minor">
+            <a:schemeClr val="lt1"/>
+          </a:fontRef>
+        </p:style>
+        <p:txBody>
+          <a:bodyPr rtlCol="0" anchor="ctr" wrap="square" lIns="182880" rIns="182880"/>
+          <a:lstStyle/>
+          <a:p>
+            <a:pPr algn="ctr"/>
+            <a:r>
+              <a:rPr sz="1200" b="1" i="0">
+                <a:solidFill>
+                  <a:srgbClr val="0E7C7B"/>
+                </a:solidFill>
+                <a:latin typeface="Menlo"/>
+              </a:rPr>
+              <a:t>MASS SPEC · </a:t>
+            </a:r>
+            <a:r>
+              <a:rPr sz="1700" b="0" i="0">
+                <a:solidFill>
+                  <a:srgbClr val="3D444C"/>
+                </a:solidFill>
+                <a:latin typeface="Avenir Next"/>
+              </a:rPr>
+              <a:t>CHAIN OF THOUGHT = asking the model to write its reasoning steps BEFORE the answer. Same question, same model: worked step by step (0.0029 → 5.5 ppm) it catches what a one-shot answer waves through. But it can only reason over numbers already in the prompt.</a:t>
+            </a:r>
+          </a:p>
+        </p:txBody>
+      </p:sp>
+      <p:pic>
+        <p:nvPicPr>
+          <p:cNvPr id="7" name="Picture 6" descr="fig_chain_of_thought.png"/>
+          <p:cNvPicPr>
+            <a:picLocks noChangeAspect="1"/>
+          </p:cNvPicPr>
+          <p:nvPr/>
+        </p:nvPicPr>
+        <p:blipFill>
+          <a:blip r:embed="rId3"/>
+          <a:stretch>
+            <a:fillRect/>
+          </a:stretch>
+        </p:blipFill>
+        <p:spPr>
+          <a:xfrm>
+            <a:off x="2122922" y="1828800"/>
+            <a:ext cx="7945851" cy="3649416"/>
+          </a:xfrm>
+          <a:prstGeom prst="rect">
+            <a:avLst/>
+          </a:prstGeom>
+        </p:spPr>
+      </p:pic>
+    </p:spTree>
+  </p:cSld>
+  <p:clrMapOvr>
+    <a:masterClrMapping/>
+  </p:clrMapOvr>
+</p:sld>
+</file>
+
 <file path=ppt/slides/slide3.xml><?xml version="1.0" encoding="utf-8"?>
 <p:sld xmlns:a="http://schemas.openxmlformats.org/drawingml/2006/main" xmlns:p="http://schemas.openxmlformats.org/presentationml/2006/main" xmlns:r="http://schemas.openxmlformats.org/officeDocument/2006/relationships">
   <p:cSld>
@@ -6511,7 +6800,7 @@
                 </a:solidFill>
                 <a:latin typeface="Menlo"/>
               </a:rPr>
-              <a:t>CHATBOT → AGENT · 1 OF 3 · THE DEFINITION · I-DO</a:t>
+              <a:t>CHATBOT → AGENT · 1 OF 4 · THE DEFINITION · I-DO</a:t>
             </a:r>
           </a:p>
         </p:txBody>
@@ -6729,7 +7018,7 @@
                 </a:solidFill>
                 <a:latin typeface="Menlo"/>
               </a:rPr>
-              <a:t>CHATBOT → AGENT · 2 OF 3 · THE REACT PATTERN · I-DO</a:t>
+              <a:t>CHATBOT → AGENT · 3 OF 4 · THE REACT PATTERN · I-DO</a:t>
             </a:r>
           </a:p>
         </p:txBody>
@@ -6947,7 +7236,7 @@
                 </a:solidFill>
                 <a:latin typeface="Menlo"/>
               </a:rPr>
-              <a:t>CHATBOT → AGENT · 3 OF 3 · YOUR TURN (YOU-DO = Q1)</a:t>
+              <a:t>CHATBOT → AGENT · 4 OF 4 · YOUR TURN (YOU-DO = Q1)</a:t>
             </a:r>
           </a:p>
         </p:txBody>

</xml_diff>